<commit_message>
feat: in-app floating live chat with 1-click PRO purchase and admin activation
</commit_message>
<xml_diff>
--- a/AdmitRoute_Presentation_8Slides.pptx
+++ b/AdmitRoute_Presentation_8Slides.pptx
@@ -5000,7 +5000,7 @@
               </a:defRPr>
             </a:pPr>
             <a:r>
-              <a:t>Индивидуальный роадмап и эссе</a:t>
+              <a:t>Индивидуальный роадмап, эссе и Live-чат</a:t>
             </a:r>
           </a:p>
           <a:p>
@@ -5016,7 +5016,7 @@
               </a:defRPr>
             </a:pPr>
             <a:r>
-              <a:t>Пошаговый таймлайн подготовки к дедлайнам с экспортом в Google/Apple календарь (.ics), печатью отчета и персональным каркасом мотивационного письма.</a:t>
+              <a:t>Пошаговый таймлайн с экспортом в календарь (.ics), персональный каркас эссе и встроенный Live-чат для консультаций и покупки PRO прямо на сайте.</a:t>
             </a:r>
           </a:p>
         </p:txBody>
@@ -5367,7 +5367,7 @@
             </a:r>
             <a:br/>
             <a:r>
-              <a:t>• Admin: панель управления, выдача PRO, бан, входящие сообщения.</a:t>
+              <a:t>• Admin: панель управления, живой мессенджер с пользователями, выдача PRO в 1 клик.</a:t>
             </a:r>
           </a:p>
         </p:txBody>
@@ -6227,7 +6227,7 @@
               </a:defRPr>
             </a:pPr>
             <a:r>
-              <a:t>Простая и масштабируемая модель с заказом подписки через чат, WhatsApp и Telegram.</a:t>
+              <a:t>Простая модель: покупка подписки прямо во встроенном чате сайта либо через WhatsApp/Telegram.</a:t>
             </a:r>
           </a:p>
         </p:txBody>

</xml_diff>

<commit_message>
feat: complete AdmitRoute platform with Super-Admin delegation, Free vs PRO pricing modal, Gemini 3.6 Flash engine, and LOCUSCASE2 submission readiness
</commit_message>
<xml_diff>
--- a/AdmitRoute_Presentation_8Slides.pptx
+++ b/AdmitRoute_Presentation_8Slides.pptx
@@ -4929,7 +4929,7 @@
               </a:defRPr>
             </a:pPr>
             <a:r>
-              <a:t>Ввод названия любого университета планеты (Тренто, Bocconi, Waterloo) — Gemini 3.6 Flash мгновенно выдает карточку с дедлайнами волн, грантами и персональным шансом.</a:t>
+              <a:t>Ввод названия любого университета (Тренто, Bocconi, Waterloo, КБТУ, СДУ) — Gemini 3.6 Flash мгновенно выдает точную карточку с волнами, грантами и персональным шансом.</a:t>
             </a:r>
           </a:p>
         </p:txBody>
@@ -5016,7 +5016,7 @@
               </a:defRPr>
             </a:pPr>
             <a:r>
-              <a:t>Пошаговый таймлайн с экспортом в календарь (.ics), персональный каркас эссе и встроенный Live-чат для консультаций и покупки PRO прямо на сайте.</a:t>
+              <a:t>Пошаговый таймлайн с экспортом в календарь (.ics), генератор каркаса эссе и встроенный Live-чат для консультаций и быстрой покупки PRO прямо на сайте.</a:t>
             </a:r>
           </a:p>
         </p:txBody>
@@ -5256,7 +5256,7 @@
               </a:defRPr>
             </a:pPr>
             <a:r>
-              <a:t>Google Gemini 3.6 Flash + No-Fail Engine</a:t>
+              <a:t>Google Gemini 3.6 Flash + Grounded Base</a:t>
             </a:r>
           </a:p>
           <a:p>
@@ -5272,7 +5272,7 @@
               </a:defRPr>
             </a:pPr>
             <a:r>
-              <a:t>Интеграция с актуальным API Gemini для генерации данных о зарубежных вузах и анализа мотивационных писем. При отсутствии сети срабатывает встроенная база знаний (Zero-Failure).</a:t>
+              <a:t>Связка новейшего API Gemini 3.6 Flash с верифицированной базой программ (130+ направлений): точные пороги ЕНТ, IELTS, реальные гранты и стоимость без галлюцинаций.</a:t>
             </a:r>
           </a:p>
         </p:txBody>
@@ -5359,15 +5359,15 @@
               </a:defRPr>
             </a:pPr>
             <a:r>
-              <a:t>• Guest: быстрый старт без барьеров, базовые квоты (до 2 поисков).</a:t>
+              <a:t>• Guest: ознакомительный доступ (1 поиск, чат только для чтения).</a:t>
             </a:r>
             <a:br/>
             <a:r>
-              <a:t>• Customer: сохранение профиля, тарифы Free и безлимитный PRO.</a:t>
+              <a:t>• Customer: сохранение профиля, меню сравнения тарифов Free vs PRO.</a:t>
             </a:r>
             <a:br/>
             <a:r>
-              <a:t>• Admin: панель управления, живой мессенджер с пользователями, выдача PRO в 1 клик.</a:t>
+              <a:t>• Super-Admin: панель управления, делегирование прав админа, чат и квоты.</a:t>
             </a:r>
           </a:p>
         </p:txBody>
@@ -6227,7 +6227,7 @@
               </a:defRPr>
             </a:pPr>
             <a:r>
-              <a:t>Простая модель: покупка подписки прямо во встроенном чате сайта либо через WhatsApp/Telegram.</a:t>
+              <a:t>Прозрачное меню сравнения тарифов Free vs PRO и мгновенная оплата во встроенном Live-чате.</a:t>
             </a:r>
           </a:p>
         </p:txBody>
@@ -6394,7 +6394,7 @@
               </a:defRPr>
             </a:pPr>
             <a:r>
-              <a:t>• Лимит: до 2 поисков через AI</a:t>
+              <a:t>• Лимит: 1 поиск гостю, 6 на Free</a:t>
             </a:r>
           </a:p>
         </p:txBody>

</xml_diff>

<commit_message>
feat(presentation): replace role model with target audience, add competitor analysis, update PDF and PPTX decks
</commit_message>
<xml_diff>
--- a/AdmitRoute_Presentation_8Slides.pptx
+++ b/AdmitRoute_Presentation_8Slides.pptx
@@ -3154,7 +3154,7 @@
         </p:blipFill>
         <p:spPr>
           <a:xfrm>
-            <a:off x="822960" y="914400"/>
+            <a:off x="822960" y="822960"/>
             <a:ext cx="1645920" cy="1645920"/>
           </a:xfrm>
           <a:prstGeom prst="rect">
@@ -3170,7 +3170,7 @@
         </p:nvSpPr>
         <p:spPr>
           <a:xfrm>
-            <a:off x="822960" y="2834640"/>
+            <a:off x="822960" y="2743200"/>
             <a:ext cx="3108960" cy="384048"/>
           </a:xfrm>
           <a:prstGeom prst="roundRect">
@@ -3225,7 +3225,7 @@
         </p:nvSpPr>
         <p:spPr>
           <a:xfrm>
-            <a:off x="822960" y="3383280"/>
+            <a:off x="822960" y="3291840"/>
             <a:ext cx="10515600" cy="1463040"/>
           </a:xfrm>
           <a:prstGeom prst="rect">
@@ -3240,7 +3240,7 @@
           <a:lstStyle/>
           <a:p>
             <a:pPr>
-              <a:defRPr sz="5200" b="1">
+              <a:defRPr sz="5000" b="1">
                 <a:solidFill>
                   <a:srgbClr val="FFFFFF"/>
                 </a:solidFill>
@@ -3254,9 +3254,9 @@
           <a:p>
             <a:pPr>
               <a:spcBef>
-                <a:spcPts val="800"/>
-              </a:spcBef>
-              <a:defRPr sz="1900">
+                <a:spcPts val="600"/>
+              </a:spcBef>
+              <a:defRPr sz="1800">
                 <a:solidFill>
                   <a:srgbClr val="94A3B8"/>
                 </a:solidFill>
@@ -3277,7 +3277,7 @@
         </p:nvSpPr>
         <p:spPr>
           <a:xfrm>
-            <a:off x="822960" y="5120640"/>
+            <a:off x="822960" y="5029200"/>
             <a:ext cx="5029200" cy="457200"/>
           </a:xfrm>
           <a:prstGeom prst="rect">
@@ -3313,7 +3313,7 @@
         </p:nvSpPr>
         <p:spPr>
           <a:xfrm>
-            <a:off x="6126480" y="5120640"/>
+            <a:off x="6126480" y="5029200"/>
             <a:ext cx="5029200" cy="457200"/>
           </a:xfrm>
           <a:prstGeom prst="rect">
@@ -3336,7 +3336,7 @@
               </a:defRPr>
             </a:pPr>
             <a:r>
-              <a:t>✓ 36+ детальных программ: Казахстан, Европа, Азия, США</a:t>
+              <a:t>✓ 36+ детальных программ + живой AI-поиск любого вуза планеты</a:t>
             </a:r>
           </a:p>
         </p:txBody>
@@ -3349,7 +3349,7 @@
         </p:nvSpPr>
         <p:spPr>
           <a:xfrm>
-            <a:off x="822960" y="5760720"/>
+            <a:off x="822960" y="5669280"/>
             <a:ext cx="5029200" cy="457200"/>
           </a:xfrm>
           <a:prstGeom prst="rect">
@@ -3372,7 +3372,7 @@
               </a:defRPr>
             </a:pPr>
             <a:r>
-              <a:t>✓ Живой поиск любого вуза планеты через Google Gemini 3.6 Flash</a:t>
+              <a:t>✓ Персональный роадмап дедлайнов, экспорт в iCal и Telegram-бот</a:t>
             </a:r>
           </a:p>
         </p:txBody>
@@ -3385,7 +3385,7 @@
         </p:nvSpPr>
         <p:spPr>
           <a:xfrm>
-            <a:off x="6126480" y="5760720"/>
+            <a:off x="6126480" y="5669280"/>
             <a:ext cx="5029200" cy="457200"/>
           </a:xfrm>
           <a:prstGeom prst="rect">
@@ -3408,7 +3408,7 @@
               </a:defRPr>
             </a:pPr>
             <a:r>
-              <a:t>✓ 3 волны дедлайнов (Early/Regular/Late) и статистика грантов</a:t>
+              <a:t>✓ Доступность для каждой семьи: 4 990 ₸ вместо $2,000 в агентствах</a:t>
             </a:r>
           </a:p>
         </p:txBody>
@@ -3483,7 +3483,7 @@
         <p:spPr>
           <a:xfrm>
             <a:off x="731520" y="411480"/>
-            <a:ext cx="10515600" cy="292608"/>
+            <a:ext cx="10698480" cy="292608"/>
           </a:xfrm>
           <a:prstGeom prst="rect">
             <a:avLst/>
@@ -3519,7 +3519,7 @@
         <p:spPr>
           <a:xfrm>
             <a:off x="731520" y="731520"/>
-            <a:ext cx="10515600" cy="548640"/>
+            <a:ext cx="10698480" cy="502920"/>
           </a:xfrm>
           <a:prstGeom prst="rect">
             <a:avLst/>
@@ -3533,7 +3533,7 @@
           <a:lstStyle/>
           <a:p>
             <a:pPr>
-              <a:defRPr sz="2300" b="1">
+              <a:defRPr sz="2200" b="1">
                 <a:solidFill>
                   <a:srgbClr val="0F172A"/>
                 </a:solidFill>
@@ -3554,8 +3554,8 @@
         </p:nvSpPr>
         <p:spPr>
           <a:xfrm>
-            <a:off x="731520" y="1280160"/>
-            <a:ext cx="10515600" cy="365760"/>
+            <a:off x="731520" y="1261872"/>
+            <a:ext cx="10698480" cy="365760"/>
           </a:xfrm>
           <a:prstGeom prst="rect">
             <a:avLst/>
@@ -3590,8 +3590,8 @@
         </p:nvSpPr>
         <p:spPr>
           <a:xfrm>
-            <a:off x="731520" y="1828800"/>
-            <a:ext cx="3383280" cy="4480560"/>
+            <a:off x="731520" y="1783080"/>
+            <a:ext cx="3383280" cy="4572000"/>
           </a:xfrm>
           <a:prstGeom prst="roundRect">
             <a:avLst/>
@@ -3670,7 +3670,7 @@
           <a:p>
             <a:pPr>
               <a:spcBef>
-                <a:spcPts val="2000"/>
+                <a:spcPts val="2400"/>
               </a:spcBef>
               <a:defRPr sz="1800" b="1">
                 <a:solidFill>
@@ -3693,7 +3693,7 @@
               </a:defRPr>
             </a:pPr>
             <a:r>
-              <a:t>тратит абитуриент на сбор информации</a:t>
+              <a:t>тратит семья на ручной сбор информации</a:t>
             </a:r>
           </a:p>
         </p:txBody>
@@ -3706,8 +3706,8 @@
         </p:nvSpPr>
         <p:spPr>
           <a:xfrm>
-            <a:off x="4389120" y="1828800"/>
-            <a:ext cx="3383280" cy="4480560"/>
+            <a:off x="4389120" y="1783080"/>
+            <a:ext cx="3383280" cy="4572000"/>
           </a:xfrm>
           <a:prstGeom prst="roundRect">
             <a:avLst/>
@@ -3786,7 +3786,7 @@
           <a:p>
             <a:pPr>
               <a:spcBef>
-                <a:spcPts val="2000"/>
+                <a:spcPts val="2400"/>
               </a:spcBef>
               <a:defRPr sz="1800" b="1">
                 <a:solidFill>
@@ -3822,8 +3822,8 @@
         </p:nvSpPr>
         <p:spPr>
           <a:xfrm>
-            <a:off x="8046720" y="1828800"/>
-            <a:ext cx="3383280" cy="4480560"/>
+            <a:off x="8046720" y="1783080"/>
+            <a:ext cx="3383280" cy="4572000"/>
           </a:xfrm>
           <a:prstGeom prst="roundRect">
             <a:avLst/>
@@ -3902,7 +3902,7 @@
           <a:p>
             <a:pPr>
               <a:spcBef>
-                <a:spcPts val="2000"/>
+                <a:spcPts val="2400"/>
               </a:spcBef>
               <a:defRPr sz="1800" b="1">
                 <a:solidFill>
@@ -4000,7 +4000,7 @@
         <p:spPr>
           <a:xfrm>
             <a:off x="731520" y="411480"/>
-            <a:ext cx="10515600" cy="292608"/>
+            <a:ext cx="10698480" cy="292608"/>
           </a:xfrm>
           <a:prstGeom prst="rect">
             <a:avLst/>
@@ -4036,7 +4036,7 @@
         <p:spPr>
           <a:xfrm>
             <a:off x="731520" y="731520"/>
-            <a:ext cx="10515600" cy="548640"/>
+            <a:ext cx="10698480" cy="502920"/>
           </a:xfrm>
           <a:prstGeom prst="rect">
             <a:avLst/>
@@ -4050,7 +4050,7 @@
           <a:lstStyle/>
           <a:p>
             <a:pPr>
-              <a:defRPr sz="2300" b="1">
+              <a:defRPr sz="2200" b="1">
                 <a:solidFill>
                   <a:srgbClr val="0F172A"/>
                 </a:solidFill>
@@ -4071,8 +4071,8 @@
         </p:nvSpPr>
         <p:spPr>
           <a:xfrm>
-            <a:off x="731520" y="1280160"/>
-            <a:ext cx="10515600" cy="365760"/>
+            <a:off x="731520" y="1261872"/>
+            <a:ext cx="10698480" cy="365760"/>
           </a:xfrm>
           <a:prstGeom prst="rect">
             <a:avLst/>
@@ -4107,8 +4107,8 @@
         </p:nvSpPr>
         <p:spPr>
           <a:xfrm>
-            <a:off x="731520" y="1828800"/>
-            <a:ext cx="3383280" cy="4480560"/>
+            <a:off x="731520" y="1783080"/>
+            <a:ext cx="3383280" cy="4572000"/>
           </a:xfrm>
           <a:prstGeom prst="roundRect">
             <a:avLst/>
@@ -4242,8 +4242,8 @@
         </p:nvSpPr>
         <p:spPr>
           <a:xfrm>
-            <a:off x="4389120" y="1828800"/>
-            <a:ext cx="3383280" cy="4480560"/>
+            <a:off x="4389120" y="1783080"/>
+            <a:ext cx="3383280" cy="4572000"/>
           </a:xfrm>
           <a:prstGeom prst="roundRect">
             <a:avLst/>
@@ -4377,8 +4377,8 @@
         </p:nvSpPr>
         <p:spPr>
           <a:xfrm>
-            <a:off x="8046720" y="1828800"/>
-            <a:ext cx="3383280" cy="4480560"/>
+            <a:off x="8046720" y="1783080"/>
+            <a:ext cx="3383280" cy="4572000"/>
           </a:xfrm>
           <a:prstGeom prst="roundRect">
             <a:avLst/>
@@ -4574,7 +4574,7 @@
         <p:spPr>
           <a:xfrm>
             <a:off x="731520" y="411480"/>
-            <a:ext cx="10515600" cy="292608"/>
+            <a:ext cx="10698480" cy="292608"/>
           </a:xfrm>
           <a:prstGeom prst="rect">
             <a:avLst/>
@@ -4596,7 +4596,7 @@
               </a:defRPr>
             </a:pPr>
             <a:r>
-              <a:t>3. ДЕМОНСТРАЦИЯ</a:t>
+              <a:t>3. ЦЕЛЕВАЯ АУДИТОРИЯ</a:t>
             </a:r>
           </a:p>
         </p:txBody>
@@ -4610,7 +4610,7 @@
         <p:spPr>
           <a:xfrm>
             <a:off x="731520" y="731520"/>
-            <a:ext cx="10515600" cy="548640"/>
+            <a:ext cx="10698480" cy="502920"/>
           </a:xfrm>
           <a:prstGeom prst="rect">
             <a:avLst/>
@@ -4624,7 +4624,7 @@
           <a:lstStyle/>
           <a:p>
             <a:pPr>
-              <a:defRPr sz="2300" b="1">
+              <a:defRPr sz="2200" b="1">
                 <a:solidFill>
                   <a:srgbClr val="0F172A"/>
                 </a:solidFill>
@@ -4632,7 +4632,7 @@
               </a:defRPr>
             </a:pPr>
             <a:r>
-              <a:t>Пользовательский путь: от анкеты до гранта за 3 минуты</a:t>
+              <a:t>Кто наши пользователи и кто принимает решение?</a:t>
             </a:r>
           </a:p>
         </p:txBody>
@@ -4645,8 +4645,8 @@
         </p:nvSpPr>
         <p:spPr>
           <a:xfrm>
-            <a:off x="731520" y="1280160"/>
-            <a:ext cx="10515600" cy="365760"/>
+            <a:off x="731520" y="1261872"/>
+            <a:ext cx="10698480" cy="365760"/>
           </a:xfrm>
           <a:prstGeom prst="rect">
             <a:avLst/>
@@ -4668,7 +4668,7 @@
               </a:defRPr>
             </a:pPr>
             <a:r>
-              <a:t>Бесшовный интерактивный сценарий, полностью закрывающий требования Кейса 02 LOCUS Hackathon.</a:t>
+              <a:t>Четкая сегментация аудитории с глубоким пониманием болей каждого сегмента и ценности AdmitRoute.</a:t>
             </a:r>
           </a:p>
         </p:txBody>
@@ -4681,8 +4681,8 @@
         </p:nvSpPr>
         <p:spPr>
           <a:xfrm>
-            <a:off x="731520" y="1828800"/>
-            <a:ext cx="5120640" cy="2057400"/>
+            <a:off x="731520" y="1783080"/>
+            <a:ext cx="3383280" cy="4572000"/>
           </a:xfrm>
           <a:prstGeom prst="roundRect">
             <a:avLst/>
@@ -4692,7 +4692,7 @@
           </a:solidFill>
           <a:ln>
             <a:solidFill>
-              <a:srgbClr val="E2E8F0"/>
+              <a:srgbClr val="2563EB"/>
             </a:solidFill>
           </a:ln>
         </p:spPr>
@@ -4711,27 +4711,139 @@
           </a:fontRef>
         </p:style>
         <p:txBody>
-          <a:bodyPr rtlCol="0" anchor="ctr" wrap="square" lIns="274320" rIns="274320" tIns="182880"/>
+          <a:bodyPr rtlCol="0" anchor="ctr" wrap="square" lIns="256032" rIns="256032" tIns="228600"/>
           <a:lstStyle/>
           <a:p>
             <a:pPr algn="ctr">
+              <a:defRPr sz="950" b="1">
+                <a:solidFill>
+                  <a:srgbClr val="2563EB"/>
+                </a:solidFill>
+                <a:latin typeface="Arial"/>
+              </a:defRPr>
+            </a:pPr>
+            <a:r>
+              <a:t>B2C • КОНЕЧНЫЙ ПОЛЬЗОВАТЕЛЬ</a:t>
+            </a:r>
+          </a:p>
+          <a:p>
+            <a:pPr>
+              <a:spcBef>
+                <a:spcPts val="400"/>
+              </a:spcBef>
+              <a:defRPr sz="1600" b="1">
+                <a:solidFill>
+                  <a:srgbClr val="0F172A"/>
+                </a:solidFill>
+                <a:latin typeface="Arial"/>
+              </a:defRPr>
+            </a:pPr>
+            <a:r>
+              <a:t>Выпускники 10–11 классов</a:t>
+            </a:r>
+          </a:p>
+          <a:p>
+            <a:pPr>
+              <a:spcBef>
+                <a:spcPts val="400"/>
+              </a:spcBef>
+              <a:defRPr sz="1050">
+                <a:solidFill>
+                  <a:srgbClr val="64748B"/>
+                </a:solidFill>
+                <a:latin typeface="Arial"/>
+              </a:defRPr>
+            </a:pPr>
+            <a:r>
+              <a:t>Учащиеся школ, лицеев, НИШ и БИЛ, нацеленные на поступление на грант в Казахстане, Европе, Азии или США.</a:t>
+            </a:r>
+          </a:p>
+          <a:p>
+            <a:pPr>
+              <a:spcBef>
+                <a:spcPts val="1000"/>
+              </a:spcBef>
               <a:defRPr sz="1000" b="1">
                 <a:solidFill>
-                  <a:srgbClr val="2563EB"/>
-                </a:solidFill>
-                <a:latin typeface="Arial"/>
-              </a:defRPr>
-            </a:pPr>
-            <a:r>
-              <a:t>ЭТАП 1</a:t>
-            </a:r>
-          </a:p>
-          <a:p>
-            <a:pPr>
-              <a:spcBef>
-                <a:spcPts val="400"/>
-              </a:spcBef>
-              <a:defRPr sz="1500" b="1">
+                  <a:srgbClr val="E11D48"/>
+                </a:solidFill>
+                <a:latin typeface="Arial"/>
+              </a:defRPr>
+            </a:pPr>
+            <a:r>
+              <a:t>КЛЮЧЕВЫЕ БОЛИ:</a:t>
+            </a:r>
+          </a:p>
+          <a:p>
+            <a:pPr>
+              <a:spcBef>
+                <a:spcPts val="200"/>
+              </a:spcBef>
+              <a:defRPr sz="950">
+                <a:solidFill>
+                  <a:srgbClr val="475569"/>
+                </a:solidFill>
+                <a:latin typeface="Arial"/>
+              </a:defRPr>
+            </a:pPr>
+            <a:r>
+              <a:t>✕ Информационный хаос (120+ часов на сайты)</a:t>
+            </a:r>
+          </a:p>
+          <a:p>
+            <a:pPr>
+              <a:spcBef>
+                <a:spcPts val="200"/>
+              </a:spcBef>
+              <a:defRPr sz="950">
+                <a:solidFill>
+                  <a:srgbClr val="475569"/>
+                </a:solidFill>
+                <a:latin typeface="Arial"/>
+              </a:defRPr>
+            </a:pPr>
+            <a:r>
+              <a:t>✕ Непонимание реальных шансов на грант</a:t>
+            </a:r>
+          </a:p>
+          <a:p>
+            <a:pPr>
+              <a:spcBef>
+                <a:spcPts val="200"/>
+              </a:spcBef>
+              <a:defRPr sz="950">
+                <a:solidFill>
+                  <a:srgbClr val="475569"/>
+                </a:solidFill>
+                <a:latin typeface="Arial"/>
+              </a:defRPr>
+            </a:pPr>
+            <a:r>
+              <a:t>✕ Страх провалить дедлайны и потерять год</a:t>
+            </a:r>
+          </a:p>
+          <a:p>
+            <a:pPr>
+              <a:spcBef>
+                <a:spcPts val="1000"/>
+              </a:spcBef>
+              <a:defRPr sz="1000" b="1">
+                <a:solidFill>
+                  <a:srgbClr val="10B981"/>
+                </a:solidFill>
+                <a:latin typeface="Arial"/>
+              </a:defRPr>
+            </a:pPr>
+            <a:r>
+              <a:t>ЦЕННОСТЬ ADMITROUTE:</a:t>
+            </a:r>
+          </a:p>
+          <a:p>
+            <a:pPr>
+              <a:spcBef>
+                <a:spcPts val="200"/>
+              </a:spcBef>
+              <a:defRPr sz="950" b="1">
                 <a:solidFill>
                   <a:srgbClr val="0F172A"/>
                 </a:solidFill>
@@ -4739,23 +4851,39 @@
               </a:defRPr>
             </a:pPr>
             <a:r>
-              <a:t>Анкета и диагностика профиля</a:t>
-            </a:r>
-          </a:p>
-          <a:p>
-            <a:pPr>
-              <a:spcBef>
-                <a:spcPts val="400"/>
-              </a:spcBef>
-              <a:defRPr sz="1100">
-                <a:solidFill>
-                  <a:srgbClr val="64748B"/>
-                </a:solidFill>
-                <a:latin typeface="Arial"/>
-              </a:defRPr>
-            </a:pPr>
-            <a:r>
-              <a:t>Ученик указывает класс, специальность, GPA, баллы IELTS/SAT/ЕНТ, бюджет и внеучебные активности. Алгоритм формирует мгновенное резюме сильных сторон и ограничений.</a:t>
+              <a:t>✓ Точный расчет шансов в % без иллюзий</a:t>
+            </a:r>
+          </a:p>
+          <a:p>
+            <a:pPr>
+              <a:spcBef>
+                <a:spcPts val="200"/>
+              </a:spcBef>
+              <a:defRPr sz="950" b="1">
+                <a:solidFill>
+                  <a:srgbClr val="0F172A"/>
+                </a:solidFill>
+                <a:latin typeface="Arial"/>
+              </a:defRPr>
+            </a:pPr>
+            <a:r>
+              <a:t>✓ Персональный роадмап и Safety-вузы</a:t>
+            </a:r>
+          </a:p>
+          <a:p>
+            <a:pPr>
+              <a:spcBef>
+                <a:spcPts val="200"/>
+              </a:spcBef>
+              <a:defRPr sz="950" b="1">
+                <a:solidFill>
+                  <a:srgbClr val="0F172A"/>
+                </a:solidFill>
+                <a:latin typeface="Arial"/>
+              </a:defRPr>
+            </a:pPr>
+            <a:r>
+              <a:t>✓ Бот в Telegram с напоминаниями дедлайнов</a:t>
             </a:r>
           </a:p>
         </p:txBody>
@@ -4768,8 +4896,8 @@
         </p:nvSpPr>
         <p:spPr>
           <a:xfrm>
-            <a:off x="6126480" y="1828800"/>
-            <a:ext cx="5120640" cy="2057400"/>
+            <a:off x="4389120" y="1783080"/>
+            <a:ext cx="3383280" cy="4572000"/>
           </a:xfrm>
           <a:prstGeom prst="roundRect">
             <a:avLst/>
@@ -4779,7 +4907,7 @@
           </a:solidFill>
           <a:ln>
             <a:solidFill>
-              <a:srgbClr val="E2E8F0"/>
+              <a:srgbClr val="7C3AED"/>
             </a:solidFill>
           </a:ln>
         </p:spPr>
@@ -4798,27 +4926,139 @@
           </a:fontRef>
         </p:style>
         <p:txBody>
-          <a:bodyPr rtlCol="0" anchor="ctr" wrap="square" lIns="274320" rIns="274320" tIns="182880"/>
+          <a:bodyPr rtlCol="0" anchor="ctr" wrap="square" lIns="256032" rIns="256032" tIns="228600"/>
           <a:lstStyle/>
           <a:p>
             <a:pPr algn="ctr">
+              <a:defRPr sz="950" b="1">
+                <a:solidFill>
+                  <a:srgbClr val="7C3AED"/>
+                </a:solidFill>
+                <a:latin typeface="Arial"/>
+              </a:defRPr>
+            </a:pPr>
+            <a:r>
+              <a:t>B2C • ПЛАТЕЛЬЩИК И СЕМЬЯ</a:t>
+            </a:r>
+          </a:p>
+          <a:p>
+            <a:pPr>
+              <a:spcBef>
+                <a:spcPts val="400"/>
+              </a:spcBef>
+              <a:defRPr sz="1600" b="1">
+                <a:solidFill>
+                  <a:srgbClr val="0F172A"/>
+                </a:solidFill>
+                <a:latin typeface="Arial"/>
+              </a:defRPr>
+            </a:pPr>
+            <a:r>
+              <a:t>Родители абитуриентов</a:t>
+            </a:r>
+          </a:p>
+          <a:p>
+            <a:pPr>
+              <a:spcBef>
+                <a:spcPts val="400"/>
+              </a:spcBef>
+              <a:defRPr sz="1050">
+                <a:solidFill>
+                  <a:srgbClr val="64748B"/>
+                </a:solidFill>
+                <a:latin typeface="Arial"/>
+              </a:defRPr>
+            </a:pPr>
+            <a:r>
+              <a:t>Принимают финансовые решения в семье, несут колоссальную эмоциональную нагрузку и оплачивают подготовку.</a:t>
+            </a:r>
+          </a:p>
+          <a:p>
+            <a:pPr>
+              <a:spcBef>
+                <a:spcPts val="1000"/>
+              </a:spcBef>
               <a:defRPr sz="1000" b="1">
                 <a:solidFill>
-                  <a:srgbClr val="2563EB"/>
-                </a:solidFill>
-                <a:latin typeface="Arial"/>
-              </a:defRPr>
-            </a:pPr>
-            <a:r>
-              <a:t>ЭТАП 2</a:t>
-            </a:r>
-          </a:p>
-          <a:p>
-            <a:pPr>
-              <a:spcBef>
-                <a:spcPts val="400"/>
-              </a:spcBef>
-              <a:defRPr sz="1500" b="1">
+                  <a:srgbClr val="E11D48"/>
+                </a:solidFill>
+                <a:latin typeface="Arial"/>
+              </a:defRPr>
+            </a:pPr>
+            <a:r>
+              <a:t>КЛЮЧЕВЫЕ БОЛИ:</a:t>
+            </a:r>
+          </a:p>
+          <a:p>
+            <a:pPr>
+              <a:spcBef>
+                <a:spcPts val="200"/>
+              </a:spcBef>
+              <a:defRPr sz="950">
+                <a:solidFill>
+                  <a:srgbClr val="475569"/>
+                </a:solidFill>
+                <a:latin typeface="Arial"/>
+              </a:defRPr>
+            </a:pPr>
+            <a:r>
+              <a:t>✕ Огромные чеки агентств ($1,500 – $4,000)</a:t>
+            </a:r>
+          </a:p>
+          <a:p>
+            <a:pPr>
+              <a:spcBef>
+                <a:spcPts val="200"/>
+              </a:spcBef>
+              <a:defRPr sz="950">
+                <a:solidFill>
+                  <a:srgbClr val="475569"/>
+                </a:solidFill>
+                <a:latin typeface="Arial"/>
+              </a:defRPr>
+            </a:pPr>
+            <a:r>
+              <a:t>✕ Риск потери бюджета и навязывание платных вузов</a:t>
+            </a:r>
+          </a:p>
+          <a:p>
+            <a:pPr>
+              <a:spcBef>
+                <a:spcPts val="200"/>
+              </a:spcBef>
+              <a:defRPr sz="950">
+                <a:solidFill>
+                  <a:srgbClr val="475569"/>
+                </a:solidFill>
+                <a:latin typeface="Arial"/>
+              </a:defRPr>
+            </a:pPr>
+            <a:r>
+              <a:t>✕ Неведение: на каком этапе подготовка ребенка</a:t>
+            </a:r>
+          </a:p>
+          <a:p>
+            <a:pPr>
+              <a:spcBef>
+                <a:spcPts val="1000"/>
+              </a:spcBef>
+              <a:defRPr sz="1000" b="1">
+                <a:solidFill>
+                  <a:srgbClr val="10B981"/>
+                </a:solidFill>
+                <a:latin typeface="Arial"/>
+              </a:defRPr>
+            </a:pPr>
+            <a:r>
+              <a:t>ЦЕННОСТЬ ADMITROUTE:</a:t>
+            </a:r>
+          </a:p>
+          <a:p>
+            <a:pPr>
+              <a:spcBef>
+                <a:spcPts val="200"/>
+              </a:spcBef>
+              <a:defRPr sz="950" b="1">
                 <a:solidFill>
                   <a:srgbClr val="0F172A"/>
                 </a:solidFill>
@@ -4826,23 +5066,39 @@
               </a:defRPr>
             </a:pPr>
             <a:r>
-              <a:t>Сбалансированные рекомендации</a:t>
-            </a:r>
-          </a:p>
-          <a:p>
-            <a:pPr>
-              <a:spcBef>
-                <a:spcPts val="400"/>
-              </a:spcBef>
-              <a:defRPr sz="1100">
-                <a:solidFill>
-                  <a:srgbClr val="64748B"/>
-                </a:solidFill>
-                <a:latin typeface="Arial"/>
-              </a:defRPr>
-            </a:pPr>
-            <a:r>
-              <a:t>Каталог из 36+ детальных программ (KZ, Азия, Европа, США) с распределением на Reach, Target и Safety. Возможность сравнения любых 2 вузов по 8 ключевым критериям.</a:t>
+              <a:t>✓ Экономия семейного бюджета (подписка 4 990 ₸)</a:t>
+            </a:r>
+          </a:p>
+          <a:p>
+            <a:pPr>
+              <a:spcBef>
+                <a:spcPts val="200"/>
+              </a:spcBef>
+              <a:defRPr sz="950" b="1">
+                <a:solidFill>
+                  <a:srgbClr val="0F172A"/>
+                </a:solidFill>
+                <a:latin typeface="Arial"/>
+              </a:defRPr>
+            </a:pPr>
+            <a:r>
+              <a:t>✓ Шеринг-ссылка для родительского контроля</a:t>
+            </a:r>
+          </a:p>
+          <a:p>
+            <a:pPr>
+              <a:spcBef>
+                <a:spcPts val="200"/>
+              </a:spcBef>
+              <a:defRPr sz="950" b="1">
+                <a:solidFill>
+                  <a:srgbClr val="0F172A"/>
+                </a:solidFill>
+                <a:latin typeface="Arial"/>
+              </a:defRPr>
+            </a:pPr>
+            <a:r>
+              <a:t>✓ Уверенность и спокойствие за будущее ребенка</a:t>
             </a:r>
           </a:p>
         </p:txBody>
@@ -4855,8 +5111,8 @@
         </p:nvSpPr>
         <p:spPr>
           <a:xfrm>
-            <a:off x="731520" y="4114800"/>
-            <a:ext cx="5120640" cy="2057400"/>
+            <a:off x="8046720" y="1783080"/>
+            <a:ext cx="3383280" cy="4572000"/>
           </a:xfrm>
           <a:prstGeom prst="roundRect">
             <a:avLst/>
@@ -4866,7 +5122,7 @@
           </a:solidFill>
           <a:ln>
             <a:solidFill>
-              <a:srgbClr val="E2E8F0"/>
+              <a:srgbClr val="10B981"/>
             </a:solidFill>
           </a:ln>
         </p:spPr>
@@ -4885,27 +5141,139 @@
           </a:fontRef>
         </p:style>
         <p:txBody>
-          <a:bodyPr rtlCol="0" anchor="ctr" wrap="square" lIns="274320" rIns="274320" tIns="182880"/>
+          <a:bodyPr rtlCol="0" anchor="ctr" wrap="square" lIns="256032" rIns="256032" tIns="228600"/>
           <a:lstStyle/>
           <a:p>
             <a:pPr algn="ctr">
+              <a:defRPr sz="950" b="1">
+                <a:solidFill>
+                  <a:srgbClr val="10B981"/>
+                </a:solidFill>
+                <a:latin typeface="Arial"/>
+              </a:defRPr>
+            </a:pPr>
+            <a:r>
+              <a:t>B2B • ПАРТНЕРСТВО И МАСШТАБ</a:t>
+            </a:r>
+          </a:p>
+          <a:p>
+            <a:pPr>
+              <a:spcBef>
+                <a:spcPts val="400"/>
+              </a:spcBef>
+              <a:defRPr sz="1600" b="1">
+                <a:solidFill>
+                  <a:srgbClr val="0F172A"/>
+                </a:solidFill>
+                <a:latin typeface="Arial"/>
+              </a:defRPr>
+            </a:pPr>
+            <a:r>
+              <a:t>Школы и EdTech-центры</a:t>
+            </a:r>
+          </a:p>
+          <a:p>
+            <a:pPr>
+              <a:spcBef>
+                <a:spcPts val="400"/>
+              </a:spcBef>
+              <a:defRPr sz="1050">
+                <a:solidFill>
+                  <a:srgbClr val="64748B"/>
+                </a:solidFill>
+                <a:latin typeface="Arial"/>
+              </a:defRPr>
+            </a:pPr>
+            <a:r>
+              <a:t>Школьные профориентаторы, образовательные центры подготовки к ЕНТ/IELTS и частные консультанты.</a:t>
+            </a:r>
+          </a:p>
+          <a:p>
+            <a:pPr>
+              <a:spcBef>
+                <a:spcPts val="1000"/>
+              </a:spcBef>
               <a:defRPr sz="1000" b="1">
                 <a:solidFill>
-                  <a:srgbClr val="2563EB"/>
-                </a:solidFill>
-                <a:latin typeface="Arial"/>
-              </a:defRPr>
-            </a:pPr>
-            <a:r>
-              <a:t>ЭТАП 3</a:t>
-            </a:r>
-          </a:p>
-          <a:p>
-            <a:pPr>
-              <a:spcBef>
-                <a:spcPts val="400"/>
-              </a:spcBef>
-              <a:defRPr sz="1500" b="1">
+                  <a:srgbClr val="E11D48"/>
+                </a:solidFill>
+                <a:latin typeface="Arial"/>
+              </a:defRPr>
+            </a:pPr>
+            <a:r>
+              <a:t>КЛЮЧЕВЫЕ БОЛИ:</a:t>
+            </a:r>
+          </a:p>
+          <a:p>
+            <a:pPr>
+              <a:spcBef>
+                <a:spcPts val="200"/>
+              </a:spcBef>
+              <a:defRPr sz="950">
+                <a:solidFill>
+                  <a:srgbClr val="475569"/>
+                </a:solidFill>
+                <a:latin typeface="Arial"/>
+              </a:defRPr>
+            </a:pPr>
+            <a:r>
+              <a:t>✕ 1 профориентатор на 200+ учеников школы</a:t>
+            </a:r>
+          </a:p>
+          <a:p>
+            <a:pPr>
+              <a:spcBef>
+                <a:spcPts val="200"/>
+              </a:spcBef>
+              <a:defRPr sz="950">
+                <a:solidFill>
+                  <a:srgbClr val="475569"/>
+                </a:solidFill>
+                <a:latin typeface="Arial"/>
+              </a:defRPr>
+            </a:pPr>
+            <a:r>
+              <a:t>✕ Ручной сбор дедлайнов в Excel-таблицах</a:t>
+            </a:r>
+          </a:p>
+          <a:p>
+            <a:pPr>
+              <a:spcBef>
+                <a:spcPts val="200"/>
+              </a:spcBef>
+              <a:defRPr sz="950">
+                <a:solidFill>
+                  <a:srgbClr val="475569"/>
+                </a:solidFill>
+                <a:latin typeface="Arial"/>
+              </a:defRPr>
+            </a:pPr>
+            <a:r>
+              <a:t>✕ Сложность составления отчетов родителям</a:t>
+            </a:r>
+          </a:p>
+          <a:p>
+            <a:pPr>
+              <a:spcBef>
+                <a:spcPts val="1000"/>
+              </a:spcBef>
+              <a:defRPr sz="1000" b="1">
+                <a:solidFill>
+                  <a:srgbClr val="10B981"/>
+                </a:solidFill>
+                <a:latin typeface="Arial"/>
+              </a:defRPr>
+            </a:pPr>
+            <a:r>
+              <a:t>ЦЕННОСТЬ ADMITROUTE:</a:t>
+            </a:r>
+          </a:p>
+          <a:p>
+            <a:pPr>
+              <a:spcBef>
+                <a:spcPts val="200"/>
+              </a:spcBef>
+              <a:defRPr sz="950" b="1">
                 <a:solidFill>
                   <a:srgbClr val="0F172A"/>
                 </a:solidFill>
@@ -4913,86 +5281,15 @@
               </a:defRPr>
             </a:pPr>
             <a:r>
-              <a:t>Живой AI-поиск любого вуза мира</a:t>
-            </a:r>
-          </a:p>
-          <a:p>
-            <a:pPr>
-              <a:spcBef>
-                <a:spcPts val="400"/>
-              </a:spcBef>
-              <a:defRPr sz="1100">
-                <a:solidFill>
-                  <a:srgbClr val="64748B"/>
-                </a:solidFill>
-                <a:latin typeface="Arial"/>
-              </a:defRPr>
-            </a:pPr>
-            <a:r>
-              <a:t>Ввод названия любого университета (Тренто, Bocconi, Waterloo, КБТУ, СДУ) — Gemini 3.6 Flash мгновенно выдает точную карточку с волнами, грантами и персональным шансом.</a:t>
-            </a:r>
-          </a:p>
-        </p:txBody>
-      </p:sp>
-      <p:sp>
-        <p:nvSpPr>
-          <p:cNvPr id="9" name="Rounded Rectangle 8"/>
-          <p:cNvSpPr/>
-          <p:nvPr/>
-        </p:nvSpPr>
-        <p:spPr>
-          <a:xfrm>
-            <a:off x="6126480" y="4114800"/>
-            <a:ext cx="5120640" cy="2057400"/>
-          </a:xfrm>
-          <a:prstGeom prst="roundRect">
-            <a:avLst/>
-          </a:prstGeom>
-          <a:solidFill>
-            <a:srgbClr val="FFFFFF"/>
-          </a:solidFill>
-          <a:ln>
-            <a:solidFill>
-              <a:srgbClr val="E2E8F0"/>
-            </a:solidFill>
-          </a:ln>
-        </p:spPr>
-        <p:style>
-          <a:lnRef idx="1">
-            <a:schemeClr val="accent1"/>
-          </a:lnRef>
-          <a:fillRef idx="3">
-            <a:schemeClr val="accent1"/>
-          </a:fillRef>
-          <a:effectRef idx="2">
-            <a:schemeClr val="accent1"/>
-          </a:effectRef>
-          <a:fontRef idx="minor">
-            <a:schemeClr val="lt1"/>
-          </a:fontRef>
-        </p:style>
-        <p:txBody>
-          <a:bodyPr rtlCol="0" anchor="ctr" wrap="square" lIns="274320" rIns="274320" tIns="182880"/>
-          <a:lstStyle/>
-          <a:p>
-            <a:pPr algn="ctr">
-              <a:defRPr sz="1000" b="1">
-                <a:solidFill>
-                  <a:srgbClr val="2563EB"/>
-                </a:solidFill>
-                <a:latin typeface="Arial"/>
-              </a:defRPr>
-            </a:pPr>
-            <a:r>
-              <a:t>ЭТАП 4</a:t>
-            </a:r>
-          </a:p>
-          <a:p>
-            <a:pPr>
-              <a:spcBef>
-                <a:spcPts val="400"/>
-              </a:spcBef>
-              <a:defRPr sz="1500" b="1">
+              <a:t>✓ Единая панель мониторинга всех учеников</a:t>
+            </a:r>
+          </a:p>
+          <a:p>
+            <a:pPr>
+              <a:spcBef>
+                <a:spcPts val="200"/>
+              </a:spcBef>
+              <a:defRPr sz="950" b="1">
                 <a:solidFill>
                   <a:srgbClr val="0F172A"/>
                 </a:solidFill>
@@ -5000,23 +5297,23 @@
               </a:defRPr>
             </a:pPr>
             <a:r>
-              <a:t>Индивидуальный роадмап, эссе и Live-чат</a:t>
-            </a:r>
-          </a:p>
-          <a:p>
-            <a:pPr>
-              <a:spcBef>
-                <a:spcPts val="400"/>
-              </a:spcBef>
-              <a:defRPr sz="1100">
-                <a:solidFill>
-                  <a:srgbClr val="64748B"/>
-                </a:solidFill>
-                <a:latin typeface="Arial"/>
-              </a:defRPr>
-            </a:pPr>
-            <a:r>
-              <a:t>Пошаговый таймлайн с экспортом в календарь (.ics), генератор каркаса эссе и встроенный Live-чат для консультаций и быстрой покупки PRO прямо на сайте.</a:t>
+              <a:t>✓ Экспорт красивых отчетов для родителей</a:t>
+            </a:r>
+          </a:p>
+          <a:p>
+            <a:pPr>
+              <a:spcBef>
+                <a:spcPts val="200"/>
+              </a:spcBef>
+              <a:defRPr sz="950" b="1">
+                <a:solidFill>
+                  <a:srgbClr val="0F172A"/>
+                </a:solidFill>
+                <a:latin typeface="Arial"/>
+              </a:defRPr>
+            </a:pPr>
+            <a:r>
+              <a:t>✓ Повышение % поступления учеников на гранты</a:t>
             </a:r>
           </a:p>
         </p:txBody>
@@ -5091,7 +5388,7 @@
         <p:spPr>
           <a:xfrm>
             <a:off x="731520" y="411480"/>
-            <a:ext cx="10515600" cy="292608"/>
+            <a:ext cx="10698480" cy="292608"/>
           </a:xfrm>
           <a:prstGeom prst="rect">
             <a:avLst/>
@@ -5113,7 +5410,7 @@
               </a:defRPr>
             </a:pPr>
             <a:r>
-              <a:t>4. ТЕХНОЛОГИИ</a:t>
+              <a:t>4. ДЕМОНСТРАЦИЯ</a:t>
             </a:r>
           </a:p>
         </p:txBody>
@@ -5127,7 +5424,7 @@
         <p:spPr>
           <a:xfrm>
             <a:off x="731520" y="731520"/>
-            <a:ext cx="10515600" cy="548640"/>
+            <a:ext cx="10698480" cy="502920"/>
           </a:xfrm>
           <a:prstGeom prst="rect">
             <a:avLst/>
@@ -5141,7 +5438,7 @@
           <a:lstStyle/>
           <a:p>
             <a:pPr>
-              <a:defRPr sz="2300" b="1">
+              <a:defRPr sz="2200" b="1">
                 <a:solidFill>
                   <a:srgbClr val="0F172A"/>
                 </a:solidFill>
@@ -5149,7 +5446,7 @@
               </a:defRPr>
             </a:pPr>
             <a:r>
-              <a:t>Архитектура решения и ролевая модель платформы</a:t>
+              <a:t>Пользовательский путь: от анкеты до гранта за 3 минуты</a:t>
             </a:r>
           </a:p>
         </p:txBody>
@@ -5162,8 +5459,8 @@
         </p:nvSpPr>
         <p:spPr>
           <a:xfrm>
-            <a:off x="731520" y="1280160"/>
-            <a:ext cx="10515600" cy="365760"/>
+            <a:off x="731520" y="1261872"/>
+            <a:ext cx="10698480" cy="365760"/>
           </a:xfrm>
           <a:prstGeom prst="rect">
             <a:avLst/>
@@ -5185,7 +5482,7 @@
               </a:defRPr>
             </a:pPr>
             <a:r>
-              <a:t>Надежный технологический стек с поддержкой 3 уровней доступа (Guest, Customer, Admin).</a:t>
+              <a:t>Бесшовный интерактивный сценарий, полностью закрывающий требования Кейса 02 LOCUS Hackathon.</a:t>
             </a:r>
           </a:p>
         </p:txBody>
@@ -5198,7 +5495,7 @@
         </p:nvSpPr>
         <p:spPr>
           <a:xfrm>
-            <a:off x="731520" y="1828800"/>
+            <a:off x="731520" y="1783080"/>
             <a:ext cx="5120640" cy="2057400"/>
           </a:xfrm>
           <a:prstGeom prst="roundRect">
@@ -5234,13 +5531,13 @@
             <a:pPr algn="ctr">
               <a:defRPr sz="1000" b="1">
                 <a:solidFill>
-                  <a:srgbClr val="7C3AED"/>
-                </a:solidFill>
-                <a:latin typeface="Arial"/>
-              </a:defRPr>
-            </a:pPr>
-            <a:r>
-              <a:t>ИСКУССТВЕННЫЙ ИНТЕЛЛЕКТ</a:t>
+                  <a:srgbClr val="2563EB"/>
+                </a:solidFill>
+                <a:latin typeface="Arial"/>
+              </a:defRPr>
+            </a:pPr>
+            <a:r>
+              <a:t>ЭТАП 1</a:t>
             </a:r>
           </a:p>
           <a:p>
@@ -5256,7 +5553,7 @@
               </a:defRPr>
             </a:pPr>
             <a:r>
-              <a:t>Google Gemini 3.6 Flash + Grounded Base</a:t>
+              <a:t>Анкета и диагностика профиля</a:t>
             </a:r>
           </a:p>
           <a:p>
@@ -5272,7 +5569,7 @@
               </a:defRPr>
             </a:pPr>
             <a:r>
-              <a:t>Связка новейшего API Gemini 3.6 Flash с верифицированной базой программ (130+ направлений): точные пороги ЕНТ, IELTS, реальные гранты и стоимость без галлюцинаций.</a:t>
+              <a:t>Ученик указывает класс, специальность, GPA, баллы IELTS/SAT/ЕНТ, бюджет и внеучебные активности. Алгоритм формирует мгновенное резюме сильных сторон и ограничений.</a:t>
             </a:r>
           </a:p>
         </p:txBody>
@@ -5285,7 +5582,7 @@
         </p:nvSpPr>
         <p:spPr>
           <a:xfrm>
-            <a:off x="6126480" y="1828800"/>
+            <a:off x="6126480" y="1783080"/>
             <a:ext cx="5120640" cy="2057400"/>
           </a:xfrm>
           <a:prstGeom prst="roundRect">
@@ -5327,7 +5624,7 @@
               </a:defRPr>
             </a:pPr>
             <a:r>
-              <a:t>3-УРОВНЕВАЯ СИСТЕМА РОЛЕЙ</a:t>
+              <a:t>ЭТАП 2</a:t>
             </a:r>
           </a:p>
           <a:p>
@@ -5343,7 +5640,7 @@
               </a:defRPr>
             </a:pPr>
             <a:r>
-              <a:t>Guest • Customer • Super-Admin</a:t>
+              <a:t>Сбалансированные рекомендации</a:t>
             </a:r>
           </a:p>
           <a:p>
@@ -5359,15 +5656,7 @@
               </a:defRPr>
             </a:pPr>
             <a:r>
-              <a:t>• Guest: ознакомительный доступ (1 поиск, чат только для чтения).</a:t>
-            </a:r>
-            <a:br/>
-            <a:r>
-              <a:t>• Customer: сохранение профиля, меню сравнения тарифов Free vs PRO.</a:t>
-            </a:r>
-            <a:br/>
-            <a:r>
-              <a:t>• Super-Admin: панель управления, делегирование прав админа, чат и квоты.</a:t>
+              <a:t>Каталог из 36+ детальных программ (KZ, Азия, Европа, США) с распределением на Reach, Target и Safety. Возможность сравнения любых 2 вузов по 8 ключевым критериям.</a:t>
             </a:r>
           </a:p>
         </p:txBody>
@@ -5380,7 +5669,7 @@
         </p:nvSpPr>
         <p:spPr>
           <a:xfrm>
-            <a:off x="731520" y="4114800"/>
+            <a:off x="731520" y="4069080"/>
             <a:ext cx="5120640" cy="2057400"/>
           </a:xfrm>
           <a:prstGeom prst="roundRect">
@@ -5422,7 +5711,7 @@
               </a:defRPr>
             </a:pPr>
             <a:r>
-              <a:t>БАЗА ДАННЫХ И ХРАНЕНИЕ</a:t>
+              <a:t>ЭТАП 3</a:t>
             </a:r>
           </a:p>
           <a:p>
@@ -5438,7 +5727,7 @@
               </a:defRPr>
             </a:pPr>
             <a:r>
-              <a:t>Автономная локальная БД (LocalStorage)</a:t>
+              <a:t>Живой AI-поиск любого вуза мира</a:t>
             </a:r>
           </a:p>
           <a:p>
@@ -5454,7 +5743,7 @@
               </a:defRPr>
             </a:pPr>
             <a:r>
-              <a:t>Полное соответствие регламенту хакатона: сохранение состояния профиля, базы пользователей, истории чата и настроек сайта без необходимости сложного сервера.</a:t>
+              <a:t>Ввод названия любого университета (Тренто, Bocconi, Waterloo, КБТУ, СДУ) — Gemini 3.6 Flash мгновенно выдает точную карточку с волнами, грантами и персональным шансом.</a:t>
             </a:r>
           </a:p>
         </p:txBody>
@@ -5467,7 +5756,7 @@
         </p:nvSpPr>
         <p:spPr>
           <a:xfrm>
-            <a:off x="6126480" y="4114800"/>
+            <a:off x="6126480" y="4069080"/>
             <a:ext cx="5120640" cy="2057400"/>
           </a:xfrm>
           <a:prstGeom prst="roundRect">
@@ -5509,7 +5798,7 @@
               </a:defRPr>
             </a:pPr>
             <a:r>
-              <a:t>СОВРЕМЕННЫЙ ФРОНТЕНД</a:t>
+              <a:t>ЭТАП 4</a:t>
             </a:r>
           </a:p>
           <a:p>
@@ -5525,7 +5814,7 @@
               </a:defRPr>
             </a:pPr>
             <a:r>
-              <a:t>React 19 • TypeScript • Vite • Tailwind</a:t>
+              <a:t>Канбан-трекер, эссе, бот и шеринг</a:t>
             </a:r>
           </a:p>
           <a:p>
@@ -5541,7 +5830,7 @@
               </a:defRPr>
             </a:pPr>
             <a:r>
-              <a:t>Мгновенная скорость работы (отклик &lt;0.2 сек), строгая типизация, адаптивность под мобильные устройства и экспорт дедлайнов в формат .ics (iCalendar).</a:t>
+              <a:t>Индивидуальный роадмап дедлайнов, экспорт в календарь (.ics), генератор каркаса эссе, Telegram-бот с уведомлениями и ссылки доступа для родителей и менторов.</a:t>
             </a:r>
           </a:p>
         </p:txBody>
@@ -5616,7 +5905,7 @@
         <p:spPr>
           <a:xfrm>
             <a:off x="731520" y="411480"/>
-            <a:ext cx="10515600" cy="292608"/>
+            <a:ext cx="10698480" cy="292608"/>
           </a:xfrm>
           <a:prstGeom prst="rect">
             <a:avLst/>
@@ -5638,7 +5927,7 @@
               </a:defRPr>
             </a:pPr>
             <a:r>
-              <a:t>5. РЫНОЧНЫЙ ПОТЕНЦИАЛ</a:t>
+              <a:t>5. КОНКУРЕНТНЫЙ АНАЛИЗ</a:t>
             </a:r>
           </a:p>
         </p:txBody>
@@ -5652,7 +5941,7 @@
         <p:spPr>
           <a:xfrm>
             <a:off x="731520" y="731520"/>
-            <a:ext cx="10515600" cy="548640"/>
+            <a:ext cx="10698480" cy="502920"/>
           </a:xfrm>
           <a:prstGeom prst="rect">
             <a:avLst/>
@@ -5666,7 +5955,7 @@
           <a:lstStyle/>
           <a:p>
             <a:pPr>
-              <a:defRPr sz="2300" b="1">
+              <a:defRPr sz="2200" b="1">
                 <a:solidFill>
                   <a:srgbClr val="0F172A"/>
                 </a:solidFill>
@@ -5674,7 +5963,7 @@
               </a:defRPr>
             </a:pPr>
             <a:r>
-              <a:t>Объем рынка и растущий спрос на зарубежные гранты</a:t>
+              <a:t>Почему AdmitRoute побеждает альтернативы на рынке?</a:t>
             </a:r>
           </a:p>
         </p:txBody>
@@ -5687,8 +5976,8 @@
         </p:nvSpPr>
         <p:spPr>
           <a:xfrm>
-            <a:off x="731520" y="1280160"/>
-            <a:ext cx="10515600" cy="365760"/>
+            <a:off x="731520" y="1261872"/>
+            <a:ext cx="10698480" cy="365760"/>
           </a:xfrm>
           <a:prstGeom prst="rect">
             <a:avLst/>
@@ -5710,7 +5999,7 @@
               </a:defRPr>
             </a:pPr>
             <a:r>
-              <a:t>Казахстан и Центральная Азия демонстрируют стремительный рост спроса на осознанное высшее образование.</a:t>
+              <a:t>Сравнение с традиционным консалтингом, обычными чат-ботами общего назначения и сайтами вузов.</a:t>
             </a:r>
           </a:p>
         </p:txBody>
@@ -5723,8 +6012,8 @@
         </p:nvSpPr>
         <p:spPr>
           <a:xfrm>
-            <a:off x="731520" y="1828800"/>
-            <a:ext cx="5120640" cy="2057400"/>
+            <a:off x="731520" y="1783080"/>
+            <a:ext cx="2542032" cy="4572000"/>
           </a:xfrm>
           <a:prstGeom prst="roundRect">
             <a:avLst/>
@@ -5732,7 +6021,7 @@
           <a:solidFill>
             <a:srgbClr val="FFFFFF"/>
           </a:solidFill>
-          <a:ln>
+          <a:ln w="12700">
             <a:solidFill>
               <a:srgbClr val="E2E8F0"/>
             </a:solidFill>
@@ -5753,19 +6042,35 @@
           </a:fontRef>
         </p:style>
         <p:txBody>
-          <a:bodyPr rtlCol="0" anchor="ctr" wrap="square" lIns="274320" rIns="274320" tIns="182880"/>
+          <a:bodyPr rtlCol="0" anchor="ctr" wrap="square" lIns="182880" rIns="182880" tIns="182880"/>
           <a:lstStyle/>
           <a:p>
             <a:pPr algn="ctr">
-              <a:defRPr sz="3000" b="1">
-                <a:solidFill>
-                  <a:srgbClr val="2563EB"/>
-                </a:solidFill>
-                <a:latin typeface="Arial"/>
-              </a:defRPr>
-            </a:pPr>
-            <a:r>
-              <a:t>180 000+</a:t>
+              <a:defRPr sz="850" b="1">
+                <a:solidFill>
+                  <a:srgbClr val="64748B"/>
+                </a:solidFill>
+                <a:latin typeface="Arial"/>
+              </a:defRPr>
+            </a:pPr>
+            <a:r>
+              <a:t>ТРАДИЦИОННЫЙ КОНСАЛТИНГ</a:t>
+            </a:r>
+          </a:p>
+          <a:p>
+            <a:pPr>
+              <a:spcBef>
+                <a:spcPts val="300"/>
+              </a:spcBef>
+              <a:defRPr sz="1350" b="1">
+                <a:solidFill>
+                  <a:srgbClr val="0F172A"/>
+                </a:solidFill>
+                <a:latin typeface="Arial"/>
+              </a:defRPr>
+            </a:pPr>
+            <a:r>
+              <a:t>Агентства поступления</a:t>
             </a:r>
           </a:p>
           <a:p>
@@ -5773,7 +6078,7 @@
               <a:spcBef>
                 <a:spcPts val="400"/>
               </a:spcBef>
-              <a:defRPr sz="1300" b="1">
+              <a:defRPr sz="1500" b="1">
                 <a:solidFill>
                   <a:srgbClr val="0F172A"/>
                 </a:solidFill>
@@ -5781,15 +6086,12 @@
               </a:defRPr>
             </a:pPr>
             <a:r>
-              <a:t>Выпускников школ в Казахстане ежегодно (TAM)</a:t>
-            </a:r>
-          </a:p>
-          <a:p>
-            <a:pPr>
-              <a:spcBef>
-                <a:spcPts val="400"/>
-              </a:spcBef>
-              <a:defRPr sz="1100">
+              <a:t>$1,500 – $4,000</a:t>
+            </a:r>
+          </a:p>
+          <a:p>
+            <a:pPr>
+              <a:defRPr sz="900">
                 <a:solidFill>
                   <a:srgbClr val="64748B"/>
                 </a:solidFill>
@@ -5797,7 +6099,103 @@
               </a:defRPr>
             </a:pPr>
             <a:r>
-              <a:t>Ежегодный растущий поток абитуриентов, поступающих в бакалавриат</a:t>
+              <a:t>за сопровождение 1 абитуриента</a:t>
+            </a:r>
+          </a:p>
+          <a:p>
+            <a:pPr>
+              <a:spcBef>
+                <a:spcPts val="500"/>
+              </a:spcBef>
+              <a:defRPr sz="900">
+                <a:solidFill>
+                  <a:srgbClr val="475569"/>
+                </a:solidFill>
+                <a:latin typeface="Arial"/>
+              </a:defRPr>
+            </a:pPr>
+            <a:r>
+              <a:t>✕ Заоблачная стоимость для 95% семей</a:t>
+            </a:r>
+          </a:p>
+          <a:p>
+            <a:pPr>
+              <a:spcBef>
+                <a:spcPts val="500"/>
+              </a:spcBef>
+              <a:defRPr sz="900">
+                <a:solidFill>
+                  <a:srgbClr val="475569"/>
+                </a:solidFill>
+                <a:latin typeface="Arial"/>
+              </a:defRPr>
+            </a:pPr>
+            <a:r>
+              <a:t>✕ Навязывают платные вузы за комиссию</a:t>
+            </a:r>
+          </a:p>
+          <a:p>
+            <a:pPr>
+              <a:spcBef>
+                <a:spcPts val="500"/>
+              </a:spcBef>
+              <a:defRPr sz="900">
+                <a:solidFill>
+                  <a:srgbClr val="475569"/>
+                </a:solidFill>
+                <a:latin typeface="Arial"/>
+              </a:defRPr>
+            </a:pPr>
+            <a:r>
+              <a:t>✕ Субъективная оценка «на глаз» куратора</a:t>
+            </a:r>
+          </a:p>
+          <a:p>
+            <a:pPr>
+              <a:spcBef>
+                <a:spcPts val="500"/>
+              </a:spcBef>
+              <a:defRPr sz="900">
+                <a:solidFill>
+                  <a:srgbClr val="475569"/>
+                </a:solidFill>
+                <a:latin typeface="Arial"/>
+              </a:defRPr>
+            </a:pPr>
+            <a:r>
+              <a:t>✕ Долгие ручные созвоны и бюрократия</a:t>
+            </a:r>
+          </a:p>
+          <a:p>
+            <a:pPr>
+              <a:spcBef>
+                <a:spcPts val="500"/>
+              </a:spcBef>
+              <a:defRPr sz="900">
+                <a:solidFill>
+                  <a:srgbClr val="475569"/>
+                </a:solidFill>
+                <a:latin typeface="Arial"/>
+              </a:defRPr>
+            </a:pPr>
+            <a:r>
+              <a:t>✕ Нет объективной гарантии гранта</a:t>
+            </a:r>
+          </a:p>
+          <a:p>
+            <a:pPr>
+              <a:spcBef>
+                <a:spcPts val="1200"/>
+              </a:spcBef>
+              <a:defRPr sz="950" b="1">
+                <a:solidFill>
+                  <a:srgbClr val="E11D48"/>
+                </a:solidFill>
+                <a:latin typeface="Arial"/>
+              </a:defRPr>
+            </a:pPr>
+            <a:r>
+              <a:t>ИТОГ: Дорого и ангажированно</a:t>
             </a:r>
           </a:p>
         </p:txBody>
@@ -5810,8 +6208,8 @@
         </p:nvSpPr>
         <p:spPr>
           <a:xfrm>
-            <a:off x="6126480" y="1828800"/>
-            <a:ext cx="5120640" cy="2057400"/>
+            <a:off x="3456432" y="1783080"/>
+            <a:ext cx="2542032" cy="4572000"/>
           </a:xfrm>
           <a:prstGeom prst="roundRect">
             <a:avLst/>
@@ -5819,7 +6217,7 @@
           <a:solidFill>
             <a:srgbClr val="FFFFFF"/>
           </a:solidFill>
-          <a:ln>
+          <a:ln w="12700">
             <a:solidFill>
               <a:srgbClr val="E2E8F0"/>
             </a:solidFill>
@@ -5840,19 +6238,35 @@
           </a:fontRef>
         </p:style>
         <p:txBody>
-          <a:bodyPr rtlCol="0" anchor="ctr" wrap="square" lIns="274320" rIns="274320" tIns="182880"/>
+          <a:bodyPr rtlCol="0" anchor="ctr" wrap="square" lIns="182880" rIns="182880" tIns="182880"/>
           <a:lstStyle/>
           <a:p>
             <a:pPr algn="ctr">
-              <a:defRPr sz="3000" b="1">
-                <a:solidFill>
-                  <a:srgbClr val="2563EB"/>
-                </a:solidFill>
-                <a:latin typeface="Arial"/>
-              </a:defRPr>
-            </a:pPr>
-            <a:r>
-              <a:t>35 000+</a:t>
+              <a:defRPr sz="850" b="1">
+                <a:solidFill>
+                  <a:srgbClr val="64748B"/>
+                </a:solidFill>
+                <a:latin typeface="Arial"/>
+              </a:defRPr>
+            </a:pPr>
+            <a:r>
+              <a:t>ОБЫЧНЫЕ ЧАТ-БОТЫ (ИИ)</a:t>
+            </a:r>
+          </a:p>
+          <a:p>
+            <a:pPr>
+              <a:spcBef>
+                <a:spcPts val="300"/>
+              </a:spcBef>
+              <a:defRPr sz="1350" b="1">
+                <a:solidFill>
+                  <a:srgbClr val="0F172A"/>
+                </a:solidFill>
+                <a:latin typeface="Arial"/>
+              </a:defRPr>
+            </a:pPr>
+            <a:r>
+              <a:t>ChatGPT / Claude / Gemini</a:t>
             </a:r>
           </a:p>
           <a:p>
@@ -5860,7 +6274,7 @@
               <a:spcBef>
                 <a:spcPts val="400"/>
               </a:spcBef>
-              <a:defRPr sz="1300" b="1">
+              <a:defRPr sz="1500" b="1">
                 <a:solidFill>
                   <a:srgbClr val="0F172A"/>
                 </a:solidFill>
@@ -5868,15 +6282,12 @@
               </a:defRPr>
             </a:pPr>
             <a:r>
-              <a:t>Абитуриентов, поступающих за рубеж (SAM)</a:t>
-            </a:r>
-          </a:p>
-          <a:p>
-            <a:pPr>
-              <a:spcBef>
-                <a:spcPts val="400"/>
-              </a:spcBef>
-              <a:defRPr sz="1100">
+              <a:t>$0 – $20 / мес</a:t>
+            </a:r>
+          </a:p>
+          <a:p>
+            <a:pPr>
+              <a:defRPr sz="900">
                 <a:solidFill>
                   <a:srgbClr val="64748B"/>
                 </a:solidFill>
@@ -5884,7 +6295,103 @@
               </a:defRPr>
             </a:pPr>
             <a:r>
-              <a:t>Высокий спрос на обучение в Европе (Италия DSU, Германия), Турции, Азии и США</a:t>
+              <a:t>подписка на веб-сервисы</a:t>
+            </a:r>
+          </a:p>
+          <a:p>
+            <a:pPr>
+              <a:spcBef>
+                <a:spcPts val="500"/>
+              </a:spcBef>
+              <a:defRPr sz="900">
+                <a:solidFill>
+                  <a:srgbClr val="475569"/>
+                </a:solidFill>
+                <a:latin typeface="Arial"/>
+              </a:defRPr>
+            </a:pPr>
+            <a:r>
+              <a:t>✕ Галлюцинации и выдуманные требования</a:t>
+            </a:r>
+          </a:p>
+          <a:p>
+            <a:pPr>
+              <a:spcBef>
+                <a:spcPts val="500"/>
+              </a:spcBef>
+              <a:defRPr sz="900">
+                <a:solidFill>
+                  <a:srgbClr val="475569"/>
+                </a:solidFill>
+                <a:latin typeface="Arial"/>
+              </a:defRPr>
+            </a:pPr>
+            <a:r>
+              <a:t>✕ Не знают порогов ЕНТ и квот РК</a:t>
+            </a:r>
+          </a:p>
+          <a:p>
+            <a:pPr>
+              <a:spcBef>
+                <a:spcPts val="500"/>
+              </a:spcBef>
+              <a:defRPr sz="900">
+                <a:solidFill>
+                  <a:srgbClr val="475569"/>
+                </a:solidFill>
+                <a:latin typeface="Arial"/>
+              </a:defRPr>
+            </a:pPr>
+            <a:r>
+              <a:t>✕ Нет математического расчета шансов</a:t>
+            </a:r>
+          </a:p>
+          <a:p>
+            <a:pPr>
+              <a:spcBef>
+                <a:spcPts val="500"/>
+              </a:spcBef>
+              <a:defRPr sz="900">
+                <a:solidFill>
+                  <a:srgbClr val="475569"/>
+                </a:solidFill>
+                <a:latin typeface="Arial"/>
+              </a:defRPr>
+            </a:pPr>
+            <a:r>
+              <a:t>✕ Нет интерактивного роадмапа и календаря</a:t>
+            </a:r>
+          </a:p>
+          <a:p>
+            <a:pPr>
+              <a:spcBef>
+                <a:spcPts val="500"/>
+              </a:spcBef>
+              <a:defRPr sz="900">
+                <a:solidFill>
+                  <a:srgbClr val="475569"/>
+                </a:solidFill>
+                <a:latin typeface="Arial"/>
+              </a:defRPr>
+            </a:pPr>
+            <a:r>
+              <a:t>✕ Нет шеринга родителям и Telegram-бота</a:t>
+            </a:r>
+          </a:p>
+          <a:p>
+            <a:pPr>
+              <a:spcBef>
+                <a:spcPts val="1200"/>
+              </a:spcBef>
+              <a:defRPr sz="950" b="1">
+                <a:solidFill>
+                  <a:srgbClr val="E11D48"/>
+                </a:solidFill>
+                <a:latin typeface="Arial"/>
+              </a:defRPr>
+            </a:pPr>
+            <a:r>
+              <a:t>ИТОГ: Риск дезинформации</a:t>
             </a:r>
           </a:p>
         </p:txBody>
@@ -5897,8 +6404,8 @@
         </p:nvSpPr>
         <p:spPr>
           <a:xfrm>
-            <a:off x="731520" y="4114800"/>
-            <a:ext cx="5120640" cy="2057400"/>
+            <a:off x="6181344" y="1783080"/>
+            <a:ext cx="2542032" cy="4572000"/>
           </a:xfrm>
           <a:prstGeom prst="roundRect">
             <a:avLst/>
@@ -5906,7 +6413,7 @@
           <a:solidFill>
             <a:srgbClr val="FFFFFF"/>
           </a:solidFill>
-          <a:ln>
+          <a:ln w="12700">
             <a:solidFill>
               <a:srgbClr val="E2E8F0"/>
             </a:solidFill>
@@ -5927,19 +6434,35 @@
           </a:fontRef>
         </p:style>
         <p:txBody>
-          <a:bodyPr rtlCol="0" anchor="ctr" wrap="square" lIns="274320" rIns="274320" tIns="182880"/>
+          <a:bodyPr rtlCol="0" anchor="ctr" wrap="square" lIns="182880" rIns="182880" tIns="182880"/>
           <a:lstStyle/>
           <a:p>
             <a:pPr algn="ctr">
-              <a:defRPr sz="3000" b="1">
-                <a:solidFill>
-                  <a:srgbClr val="2563EB"/>
-                </a:solidFill>
-                <a:latin typeface="Arial"/>
-              </a:defRPr>
-            </a:pPr>
-            <a:r>
-              <a:t>75 000+</a:t>
+              <a:defRPr sz="850" b="1">
+                <a:solidFill>
+                  <a:srgbClr val="64748B"/>
+                </a:solidFill>
+                <a:latin typeface="Arial"/>
+              </a:defRPr>
+            </a:pPr>
+            <a:r>
+              <a:t>КАТАЛОГИ И САЙТЫ ВУЗОВ</a:t>
+            </a:r>
+          </a:p>
+          <a:p>
+            <a:pPr>
+              <a:spcBef>
+                <a:spcPts val="300"/>
+              </a:spcBef>
+              <a:defRPr sz="1350" b="1">
+                <a:solidFill>
+                  <a:srgbClr val="0F172A"/>
+                </a:solidFill>
+                <a:latin typeface="Arial"/>
+              </a:defRPr>
+            </a:pPr>
+            <a:r>
+              <a:t>Kundelik, сайты вузов</a:t>
             </a:r>
           </a:p>
           <a:p>
@@ -5947,7 +6470,7 @@
               <a:spcBef>
                 <a:spcPts val="400"/>
               </a:spcBef>
-              <a:defRPr sz="1300" b="1">
+              <a:defRPr sz="1500" b="1">
                 <a:solidFill>
                   <a:srgbClr val="0F172A"/>
                 </a:solidFill>
@@ -5955,15 +6478,12 @@
               </a:defRPr>
             </a:pPr>
             <a:r>
-              <a:t>Государственных грантов РК</a:t>
-            </a:r>
-          </a:p>
-          <a:p>
-            <a:pPr>
-              <a:spcBef>
-                <a:spcPts val="400"/>
-              </a:spcBef>
-              <a:defRPr sz="1100">
+              <a:t>0 ₸ (Бесплатно)</a:t>
+            </a:r>
+          </a:p>
+          <a:p>
+            <a:pPr>
+              <a:defRPr sz="900">
                 <a:solidFill>
                   <a:srgbClr val="64748B"/>
                 </a:solidFill>
@@ -5971,7 +6491,103 @@
               </a:defRPr>
             </a:pPr>
             <a:r>
-              <a:t>Жесткая конкуренция требует точного сопоставления баллов с проходными порогами</a:t>
+              <a:t>открытые веб-страницы</a:t>
+            </a:r>
+          </a:p>
+          <a:p>
+            <a:pPr>
+              <a:spcBef>
+                <a:spcPts val="500"/>
+              </a:spcBef>
+              <a:defRPr sz="900">
+                <a:solidFill>
+                  <a:srgbClr val="475569"/>
+                </a:solidFill>
+                <a:latin typeface="Arial"/>
+              </a:defRPr>
+            </a:pPr>
+            <a:r>
+              <a:t>✕ Разрозненный хаос на сотнях сайтов</a:t>
+            </a:r>
+          </a:p>
+          <a:p>
+            <a:pPr>
+              <a:spcBef>
+                <a:spcPts val="500"/>
+              </a:spcBef>
+              <a:defRPr sz="900">
+                <a:solidFill>
+                  <a:srgbClr val="475569"/>
+                </a:solidFill>
+                <a:latin typeface="Arial"/>
+              </a:defRPr>
+            </a:pPr>
+            <a:r>
+              <a:t>✕ Устаревшие правила и даты волн</a:t>
+            </a:r>
+          </a:p>
+          <a:p>
+            <a:pPr>
+              <a:spcBef>
+                <a:spcPts val="500"/>
+              </a:spcBef>
+              <a:defRPr sz="900">
+                <a:solidFill>
+                  <a:srgbClr val="475569"/>
+                </a:solidFill>
+                <a:latin typeface="Arial"/>
+              </a:defRPr>
+            </a:pPr>
+            <a:r>
+              <a:t>✕ Нет адаптации под баллы студента</a:t>
+            </a:r>
+          </a:p>
+          <a:p>
+            <a:pPr>
+              <a:spcBef>
+                <a:spcPts val="500"/>
+              </a:spcBef>
+              <a:defRPr sz="900">
+                <a:solidFill>
+                  <a:srgbClr val="475569"/>
+                </a:solidFill>
+                <a:latin typeface="Arial"/>
+              </a:defRPr>
+            </a:pPr>
+            <a:r>
+              <a:t>✕ Нет защиты от ложных надежд</a:t>
+            </a:r>
+          </a:p>
+          <a:p>
+            <a:pPr>
+              <a:spcBef>
+                <a:spcPts val="500"/>
+              </a:spcBef>
+              <a:defRPr sz="900">
+                <a:solidFill>
+                  <a:srgbClr val="475569"/>
+                </a:solidFill>
+                <a:latin typeface="Arial"/>
+              </a:defRPr>
+            </a:pPr>
+            <a:r>
+              <a:t>✕ 120+ часов на ручной поиск данных</a:t>
+            </a:r>
+          </a:p>
+          <a:p>
+            <a:pPr>
+              <a:spcBef>
+                <a:spcPts val="1200"/>
+              </a:spcBef>
+              <a:defRPr sz="950" b="1">
+                <a:solidFill>
+                  <a:srgbClr val="E11D48"/>
+                </a:solidFill>
+                <a:latin typeface="Arial"/>
+              </a:defRPr>
+            </a:pPr>
+            <a:r>
+              <a:t>ИТОГ: Информационный хаос</a:t>
             </a:r>
           </a:p>
         </p:txBody>
@@ -5984,18 +6600,18 @@
         </p:nvSpPr>
         <p:spPr>
           <a:xfrm>
-            <a:off x="6126480" y="4114800"/>
-            <a:ext cx="5120640" cy="2057400"/>
+            <a:off x="8906256" y="1783080"/>
+            <a:ext cx="2542032" cy="4572000"/>
           </a:xfrm>
           <a:prstGeom prst="roundRect">
             <a:avLst/>
           </a:prstGeom>
           <a:solidFill>
-            <a:srgbClr val="FFFFFF"/>
+            <a:srgbClr val="EEF2FF"/>
           </a:solidFill>
-          <a:ln>
+          <a:ln w="25400">
             <a:solidFill>
-              <a:srgbClr val="E2E8F0"/>
+              <a:srgbClr val="2563EB"/>
             </a:solidFill>
           </a:ln>
         </p:spPr>
@@ -6014,11 +6630,11 @@
           </a:fontRef>
         </p:style>
         <p:txBody>
-          <a:bodyPr rtlCol="0" anchor="ctr" wrap="square" lIns="274320" rIns="274320" tIns="182880"/>
+          <a:bodyPr rtlCol="0" anchor="ctr" wrap="square" lIns="182880" rIns="182880" tIns="182880"/>
           <a:lstStyle/>
           <a:p>
             <a:pPr algn="ctr">
-              <a:defRPr sz="3000" b="1">
+              <a:defRPr sz="850" b="1">
                 <a:solidFill>
                   <a:srgbClr val="2563EB"/>
                 </a:solidFill>
@@ -6026,7 +6642,23 @@
               </a:defRPr>
             </a:pPr>
             <a:r>
-              <a:t>+38%</a:t>
+              <a:t>НАШЕ ПРЕИМУЩЕСТВО</a:t>
+            </a:r>
+          </a:p>
+          <a:p>
+            <a:pPr>
+              <a:spcBef>
+                <a:spcPts val="300"/>
+              </a:spcBef>
+              <a:defRPr sz="1350" b="1">
+                <a:solidFill>
+                  <a:srgbClr val="2563EB"/>
+                </a:solidFill>
+                <a:latin typeface="Arial"/>
+              </a:defRPr>
+            </a:pPr>
+            <a:r>
+              <a:t>AdmitRoute (Победитель)</a:t>
             </a:r>
           </a:p>
           <a:p>
@@ -6034,7 +6666,7 @@
               <a:spcBef>
                 <a:spcPts val="400"/>
               </a:spcBef>
-              <a:defRPr sz="1300" b="1">
+              <a:defRPr sz="1500" b="1">
                 <a:solidFill>
                   <a:srgbClr val="0F172A"/>
                 </a:solidFill>
@@ -6042,15 +6674,12 @@
               </a:defRPr>
             </a:pPr>
             <a:r>
-              <a:t>Ежегодный рост запросов на гранты и стипендии</a:t>
-            </a:r>
-          </a:p>
-          <a:p>
-            <a:pPr>
-              <a:spcBef>
-                <a:spcPts val="400"/>
-              </a:spcBef>
-              <a:defRPr sz="1100">
+              <a:t>0 ₸ / 4 990 ₸ мес</a:t>
+            </a:r>
+          </a:p>
+          <a:p>
+            <a:pPr>
+              <a:defRPr sz="900">
                 <a:solidFill>
                   <a:srgbClr val="64748B"/>
                 </a:solidFill>
@@ -6058,7 +6687,103 @@
               </a:defRPr>
             </a:pPr>
             <a:r>
-              <a:t>Растущая потребность в программах полного финансирования: DSU, Stipendium, CSC</a:t>
+              <a:t>Freemium + доступный PRO</a:t>
+            </a:r>
+          </a:p>
+          <a:p>
+            <a:pPr>
+              <a:spcBef>
+                <a:spcPts val="500"/>
+              </a:spcBef>
+              <a:defRPr sz="900" b="1">
+                <a:solidFill>
+                  <a:srgbClr val="0F172A"/>
+                </a:solidFill>
+                <a:latin typeface="Arial"/>
+              </a:defRPr>
+            </a:pPr>
+            <a:r>
+              <a:t>✓ Математический скоринг шансов в %</a:t>
+            </a:r>
+          </a:p>
+          <a:p>
+            <a:pPr>
+              <a:spcBef>
+                <a:spcPts val="500"/>
+              </a:spcBef>
+              <a:defRPr sz="900" b="1">
+                <a:solidFill>
+                  <a:srgbClr val="0F172A"/>
+                </a:solidFill>
+                <a:latin typeface="Arial"/>
+              </a:defRPr>
+            </a:pPr>
+            <a:r>
+              <a:t>✓ Алгоритм «Анти-иллюзия» против отказа</a:t>
+            </a:r>
+          </a:p>
+          <a:p>
+            <a:pPr>
+              <a:spcBef>
+                <a:spcPts val="500"/>
+              </a:spcBef>
+              <a:defRPr sz="900" b="1">
+                <a:solidFill>
+                  <a:srgbClr val="0F172A"/>
+                </a:solidFill>
+                <a:latin typeface="Arial"/>
+              </a:defRPr>
+            </a:pPr>
+            <a:r>
+              <a:t>✓ База РК и мира + живой AI-поиск</a:t>
+            </a:r>
+          </a:p>
+          <a:p>
+            <a:pPr>
+              <a:spcBef>
+                <a:spcPts val="500"/>
+              </a:spcBef>
+              <a:defRPr sz="900" b="1">
+                <a:solidFill>
+                  <a:srgbClr val="0F172A"/>
+                </a:solidFill>
+                <a:latin typeface="Arial"/>
+              </a:defRPr>
+            </a:pPr>
+            <a:r>
+              <a:t>✓ Дедлайны в iCal + Telegram-напоминания</a:t>
+            </a:r>
+          </a:p>
+          <a:p>
+            <a:pPr>
+              <a:spcBef>
+                <a:spcPts val="500"/>
+              </a:spcBef>
+              <a:defRPr sz="900" b="1">
+                <a:solidFill>
+                  <a:srgbClr val="0F172A"/>
+                </a:solidFill>
+                <a:latin typeface="Arial"/>
+              </a:defRPr>
+            </a:pPr>
+            <a:r>
+              <a:t>✓ Шеринг-ссылки для родителей и менторов</a:t>
+            </a:r>
+          </a:p>
+          <a:p>
+            <a:pPr>
+              <a:spcBef>
+                <a:spcPts val="1200"/>
+              </a:spcBef>
+              <a:defRPr sz="950" b="1">
+                <a:solidFill>
+                  <a:srgbClr val="2563EB"/>
+                </a:solidFill>
+                <a:latin typeface="Arial"/>
+              </a:defRPr>
+            </a:pPr>
+            <a:r>
+              <a:t>ИТОГ: Честно, точно и доступно</a:t>
             </a:r>
           </a:p>
         </p:txBody>
@@ -6133,7 +6858,7 @@
         <p:spPr>
           <a:xfrm>
             <a:off x="731520" y="411480"/>
-            <a:ext cx="10515600" cy="292608"/>
+            <a:ext cx="10698480" cy="292608"/>
           </a:xfrm>
           <a:prstGeom prst="rect">
             <a:avLst/>
@@ -6155,7 +6880,7 @@
               </a:defRPr>
             </a:pPr>
             <a:r>
-              <a:t>6. БИЗНЕС-МОДЕЛЬ</a:t>
+              <a:t>6. РЫНОК И БИЗНЕС-МОДЕЛЬ</a:t>
             </a:r>
           </a:p>
         </p:txBody>
@@ -6169,7 +6894,7 @@
         <p:spPr>
           <a:xfrm>
             <a:off x="731520" y="731520"/>
-            <a:ext cx="10515600" cy="548640"/>
+            <a:ext cx="10698480" cy="502920"/>
           </a:xfrm>
           <a:prstGeom prst="rect">
             <a:avLst/>
@@ -6183,7 +6908,7 @@
           <a:lstStyle/>
           <a:p>
             <a:pPr>
-              <a:defRPr sz="2300" b="1">
+              <a:defRPr sz="2200" b="1">
                 <a:solidFill>
                   <a:srgbClr val="0F172A"/>
                 </a:solidFill>
@@ -6191,7 +6916,7 @@
               </a:defRPr>
             </a:pPr>
             <a:r>
-              <a:t>Монетизация: B2C подписка и B2B партнерства</a:t>
+              <a:t>Объем рынка и масштабируемая монетизация</a:t>
             </a:r>
           </a:p>
         </p:txBody>
@@ -6204,8 +6929,8 @@
         </p:nvSpPr>
         <p:spPr>
           <a:xfrm>
-            <a:off x="731520" y="1280160"/>
-            <a:ext cx="10515600" cy="365760"/>
+            <a:off x="731520" y="1261872"/>
+            <a:ext cx="10698480" cy="365760"/>
           </a:xfrm>
           <a:prstGeom prst="rect">
             <a:avLst/>
@@ -6227,21 +6952,56 @@
               </a:defRPr>
             </a:pPr>
             <a:r>
-              <a:t>Прозрачное меню сравнения тарифов Free vs PRO и мгновенная оплата во встроенном Live-чате.</a:t>
-            </a:r>
-          </a:p>
-        </p:txBody>
-      </p:sp>
-      <p:sp>
-        <p:nvSpPr>
-          <p:cNvPr id="6" name="Rounded Rectangle 5"/>
+              <a:t>Растущий спрос на гранты в Казахстане и устойчивая Unit-экономика: Freemium, B2C PRO и B2B.</a:t>
+            </a:r>
+          </a:p>
+        </p:txBody>
+      </p:sp>
+      <p:sp>
+        <p:nvSpPr>
+          <p:cNvPr id="6" name="TextBox 5"/>
+          <p:cNvSpPr txBox="1"/>
+          <p:nvPr/>
+        </p:nvSpPr>
+        <p:spPr>
+          <a:xfrm>
+            <a:off x="731520" y="1783080"/>
+            <a:ext cx="5120640" cy="320040"/>
+          </a:xfrm>
+          <a:prstGeom prst="rect">
+            <a:avLst/>
+          </a:prstGeom>
+          <a:noFill/>
+        </p:spPr>
+        <p:txBody>
+          <a:bodyPr wrap="none">
+            <a:spAutoFit/>
+          </a:bodyPr>
+          <a:lstStyle/>
+          <a:p>
+            <a:pPr>
+              <a:defRPr sz="1100" b="1">
+                <a:solidFill>
+                  <a:srgbClr val="2563EB"/>
+                </a:solidFill>
+              </a:defRPr>
+            </a:pPr>
+            <a:r>
+              <a:t>РЫНОЧНЫЙ ОБЪЕМ (TAM / SAM / SOM)</a:t>
+            </a:r>
+          </a:p>
+        </p:txBody>
+      </p:sp>
+      <p:sp>
+        <p:nvSpPr>
+          <p:cNvPr id="7" name="Rounded Rectangle 6"/>
           <p:cNvSpPr/>
           <p:nvPr/>
         </p:nvSpPr>
         <p:spPr>
           <a:xfrm>
-            <a:off x="731520" y="1828800"/>
-            <a:ext cx="3383280" cy="4480560"/>
+            <a:off x="731520" y="2148840"/>
+            <a:ext cx="2468880" cy="1874519"/>
           </a:xfrm>
           <a:prstGeom prst="roundRect">
             <a:avLst/>
@@ -6270,298 +7030,35 @@
           </a:fontRef>
         </p:style>
         <p:txBody>
-          <a:bodyPr rtlCol="0" anchor="ctr" wrap="square" lIns="274320" rIns="274320" tIns="228600"/>
+          <a:bodyPr rtlCol="0" anchor="ctr" wrap="square" lIns="182880" rIns="182880" tIns="182880"/>
           <a:lstStyle/>
           <a:p>
             <a:pPr algn="ctr">
+              <a:defRPr sz="2200" b="1">
+                <a:solidFill>
+                  <a:srgbClr val="2563EB"/>
+                </a:solidFill>
+                <a:latin typeface="Arial"/>
+              </a:defRPr>
+            </a:pPr>
+            <a:r>
+              <a:t>180 000+</a:t>
+            </a:r>
+          </a:p>
+          <a:p>
+            <a:pPr>
+              <a:spcBef>
+                <a:spcPts val="400"/>
+              </a:spcBef>
               <a:defRPr sz="1000" b="1">
                 <a:solidFill>
-                  <a:srgbClr val="64748B"/>
-                </a:solidFill>
-                <a:latin typeface="Arial"/>
-              </a:defRPr>
-            </a:pPr>
-            <a:r>
-              <a:t>БЕСПЛАТНО</a:t>
-            </a:r>
-          </a:p>
-          <a:p>
-            <a:pPr>
-              <a:spcBef>
-                <a:spcPts val="400"/>
-              </a:spcBef>
-              <a:defRPr sz="2200" b="1">
-                <a:solidFill>
                   <a:srgbClr val="0F172A"/>
                 </a:solidFill>
                 <a:latin typeface="Arial"/>
               </a:defRPr>
             </a:pPr>
             <a:r>
-              <a:t>0 ₸</a:t>
-            </a:r>
-          </a:p>
-          <a:p>
-            <a:pPr>
-              <a:spcBef>
-                <a:spcPts val="200"/>
-              </a:spcBef>
-              <a:defRPr sz="1500" b="1">
-                <a:solidFill>
-                  <a:srgbClr val="0F172A"/>
-                </a:solidFill>
-                <a:latin typeface="Arial"/>
-              </a:defRPr>
-            </a:pPr>
-            <a:r>
-              <a:t>Freemium (Базовый)</a:t>
-            </a:r>
-          </a:p>
-          <a:p>
-            <a:pPr>
-              <a:spcBef>
-                <a:spcPts val="400"/>
-              </a:spcBef>
-              <a:defRPr sz="1000">
-                <a:solidFill>
-                  <a:srgbClr val="64748B"/>
-                </a:solidFill>
-                <a:latin typeface="Arial"/>
-              </a:defRPr>
-            </a:pPr>
-            <a:r>
-              <a:t>Максимальный органический охват абитуриентов:</a:t>
-            </a:r>
-          </a:p>
-          <a:p>
-            <a:pPr>
-              <a:spcBef>
-                <a:spcPts val="600"/>
-              </a:spcBef>
-              <a:defRPr sz="1000">
-                <a:solidFill>
-                  <a:srgbClr val="0F172A"/>
-                </a:solidFill>
-                <a:latin typeface="Arial"/>
-              </a:defRPr>
-            </a:pPr>
-            <a:r>
-              <a:t>• Расчет шансов в топ-36 университетов</a:t>
-            </a:r>
-          </a:p>
-          <a:p>
-            <a:pPr>
-              <a:spcBef>
-                <a:spcPts val="600"/>
-              </a:spcBef>
-              <a:defRPr sz="1000">
-                <a:solidFill>
-                  <a:srgbClr val="0F172A"/>
-                </a:solidFill>
-                <a:latin typeface="Arial"/>
-              </a:defRPr>
-            </a:pPr>
-            <a:r>
-              <a:t>• Классификация Safety / Target / Reach</a:t>
-            </a:r>
-          </a:p>
-          <a:p>
-            <a:pPr>
-              <a:spcBef>
-                <a:spcPts val="600"/>
-              </a:spcBef>
-              <a:defRPr sz="1000">
-                <a:solidFill>
-                  <a:srgbClr val="0F172A"/>
-                </a:solidFill>
-                <a:latin typeface="Arial"/>
-              </a:defRPr>
-            </a:pPr>
-            <a:r>
-              <a:t>• Базовый роадмап и 3 волны дедлайнов</a:t>
-            </a:r>
-          </a:p>
-          <a:p>
-            <a:pPr>
-              <a:spcBef>
-                <a:spcPts val="600"/>
-              </a:spcBef>
-              <a:defRPr sz="1000">
-                <a:solidFill>
-                  <a:srgbClr val="0F172A"/>
-                </a:solidFill>
-                <a:latin typeface="Arial"/>
-              </a:defRPr>
-            </a:pPr>
-            <a:r>
-              <a:t>• Лимит: 1 поиск гостю, 6 на Free</a:t>
-            </a:r>
-          </a:p>
-        </p:txBody>
-      </p:sp>
-      <p:sp>
-        <p:nvSpPr>
-          <p:cNvPr id="7" name="Rounded Rectangle 6"/>
-          <p:cNvSpPr/>
-          <p:nvPr/>
-        </p:nvSpPr>
-        <p:spPr>
-          <a:xfrm>
-            <a:off x="4389120" y="1828800"/>
-            <a:ext cx="3383280" cy="4480560"/>
-          </a:xfrm>
-          <a:prstGeom prst="roundRect">
-            <a:avLst/>
-          </a:prstGeom>
-          <a:solidFill>
-            <a:srgbClr val="FFFFFF"/>
-          </a:solidFill>
-          <a:ln>
-            <a:solidFill>
-              <a:srgbClr val="2563EB"/>
-            </a:solidFill>
-          </a:ln>
-        </p:spPr>
-        <p:style>
-          <a:lnRef idx="1">
-            <a:schemeClr val="accent1"/>
-          </a:lnRef>
-          <a:fillRef idx="3">
-            <a:schemeClr val="accent1"/>
-          </a:fillRef>
-          <a:effectRef idx="2">
-            <a:schemeClr val="accent1"/>
-          </a:effectRef>
-          <a:fontRef idx="minor">
-            <a:schemeClr val="lt1"/>
-          </a:fontRef>
-        </p:style>
-        <p:txBody>
-          <a:bodyPr rtlCol="0" anchor="ctr" wrap="square" lIns="274320" rIns="274320" tIns="228600"/>
-          <a:lstStyle/>
-          <a:p>
-            <a:pPr algn="ctr">
-              <a:defRPr sz="1000" b="1">
-                <a:solidFill>
-                  <a:srgbClr val="2563EB"/>
-                </a:solidFill>
-                <a:latin typeface="Arial"/>
-              </a:defRPr>
-            </a:pPr>
-            <a:r>
-              <a:t>ХИТ ПРОДАЖ</a:t>
-            </a:r>
-          </a:p>
-          <a:p>
-            <a:pPr>
-              <a:spcBef>
-                <a:spcPts val="400"/>
-              </a:spcBef>
-              <a:defRPr sz="2200" b="1">
-                <a:solidFill>
-                  <a:srgbClr val="0F172A"/>
-                </a:solidFill>
-                <a:latin typeface="Arial"/>
-              </a:defRPr>
-            </a:pPr>
-            <a:r>
-              <a:t>4 990 ₸ / мес</a:t>
-            </a:r>
-          </a:p>
-          <a:p>
-            <a:pPr>
-              <a:spcBef>
-                <a:spcPts val="200"/>
-              </a:spcBef>
-              <a:defRPr sz="1500" b="1">
-                <a:solidFill>
-                  <a:srgbClr val="0F172A"/>
-                </a:solidFill>
-                <a:latin typeface="Arial"/>
-              </a:defRPr>
-            </a:pPr>
-            <a:r>
-              <a:t>AdmitRoute PRO</a:t>
-            </a:r>
-          </a:p>
-          <a:p>
-            <a:pPr>
-              <a:spcBef>
-                <a:spcPts val="400"/>
-              </a:spcBef>
-              <a:defRPr sz="1000">
-                <a:solidFill>
-                  <a:srgbClr val="64748B"/>
-                </a:solidFill>
-                <a:latin typeface="Arial"/>
-              </a:defRPr>
-            </a:pPr>
-            <a:r>
-              <a:t>Для абитуриентов, нацеленных на гранты и зарубеж:</a:t>
-            </a:r>
-          </a:p>
-          <a:p>
-            <a:pPr>
-              <a:spcBef>
-                <a:spcPts val="600"/>
-              </a:spcBef>
-              <a:defRPr sz="1000">
-                <a:solidFill>
-                  <a:srgbClr val="0F172A"/>
-                </a:solidFill>
-                <a:latin typeface="Arial"/>
-              </a:defRPr>
-            </a:pPr>
-            <a:r>
-              <a:t>• Безлимитный AI-поиск любого вуза мира</a:t>
-            </a:r>
-          </a:p>
-          <a:p>
-            <a:pPr>
-              <a:spcBef>
-                <a:spcPts val="600"/>
-              </a:spcBef>
-              <a:defRPr sz="1000">
-                <a:solidFill>
-                  <a:srgbClr val="0F172A"/>
-                </a:solidFill>
-                <a:latin typeface="Arial"/>
-              </a:defRPr>
-            </a:pPr>
-            <a:r>
-              <a:t>• Генератор каркаса эссе (Personal Statement)</a:t>
-            </a:r>
-          </a:p>
-          <a:p>
-            <a:pPr>
-              <a:spcBef>
-                <a:spcPts val="600"/>
-              </a:spcBef>
-              <a:defRPr sz="1000">
-                <a:solidFill>
-                  <a:srgbClr val="0F172A"/>
-                </a:solidFill>
-                <a:latin typeface="Arial"/>
-              </a:defRPr>
-            </a:pPr>
-            <a:r>
-              <a:t>• Глубокий аудит портфолио и активностей</a:t>
-            </a:r>
-          </a:p>
-          <a:p>
-            <a:pPr>
-              <a:spcBef>
-                <a:spcPts val="600"/>
-              </a:spcBef>
-              <a:defRPr sz="1000">
-                <a:solidFill>
-                  <a:srgbClr val="0F172A"/>
-                </a:solidFill>
-                <a:latin typeface="Arial"/>
-              </a:defRPr>
-            </a:pPr>
-            <a:r>
-              <a:t>• Прямой чат с основателем по поступлению</a:t>
+              <a:t>Выпускников школ в РК ежегодно (TAM)</a:t>
             </a:r>
           </a:p>
         </p:txBody>
@@ -6574,8 +7071,8 @@
         </p:nvSpPr>
         <p:spPr>
           <a:xfrm>
-            <a:off x="8046720" y="1828800"/>
-            <a:ext cx="3383280" cy="4480560"/>
+            <a:off x="3337560" y="2148840"/>
+            <a:ext cx="2468880" cy="1874519"/>
           </a:xfrm>
           <a:prstGeom prst="roundRect">
             <a:avLst/>
@@ -6604,27 +7101,401 @@
           </a:fontRef>
         </p:style>
         <p:txBody>
-          <a:bodyPr rtlCol="0" anchor="ctr" wrap="square" lIns="274320" rIns="274320" tIns="228600"/>
+          <a:bodyPr rtlCol="0" anchor="ctr" wrap="square" lIns="182880" rIns="182880" tIns="182880"/>
           <a:lstStyle/>
           <a:p>
             <a:pPr algn="ctr">
+              <a:defRPr sz="2200" b="1">
+                <a:solidFill>
+                  <a:srgbClr val="2563EB"/>
+                </a:solidFill>
+                <a:latin typeface="Arial"/>
+              </a:defRPr>
+            </a:pPr>
+            <a:r>
+              <a:t>35 000+</a:t>
+            </a:r>
+          </a:p>
+          <a:p>
+            <a:pPr>
+              <a:spcBef>
+                <a:spcPts val="400"/>
+              </a:spcBef>
               <a:defRPr sz="1000" b="1">
                 <a:solidFill>
+                  <a:srgbClr val="0F172A"/>
+                </a:solidFill>
+                <a:latin typeface="Arial"/>
+              </a:defRPr>
+            </a:pPr>
+            <a:r>
+              <a:t>Абитуриентов за рубеж (SAM: Европа, Азия, США)</a:t>
+            </a:r>
+          </a:p>
+        </p:txBody>
+      </p:sp>
+      <p:sp>
+        <p:nvSpPr>
+          <p:cNvPr id="9" name="Rounded Rectangle 8"/>
+          <p:cNvSpPr/>
+          <p:nvPr/>
+        </p:nvSpPr>
+        <p:spPr>
+          <a:xfrm>
+            <a:off x="731520" y="4206240"/>
+            <a:ext cx="2468880" cy="1874519"/>
+          </a:xfrm>
+          <a:prstGeom prst="roundRect">
+            <a:avLst/>
+          </a:prstGeom>
+          <a:solidFill>
+            <a:srgbClr val="FFFFFF"/>
+          </a:solidFill>
+          <a:ln>
+            <a:solidFill>
+              <a:srgbClr val="E2E8F0"/>
+            </a:solidFill>
+          </a:ln>
+        </p:spPr>
+        <p:style>
+          <a:lnRef idx="1">
+            <a:schemeClr val="accent1"/>
+          </a:lnRef>
+          <a:fillRef idx="3">
+            <a:schemeClr val="accent1"/>
+          </a:fillRef>
+          <a:effectRef idx="2">
+            <a:schemeClr val="accent1"/>
+          </a:effectRef>
+          <a:fontRef idx="minor">
+            <a:schemeClr val="lt1"/>
+          </a:fontRef>
+        </p:style>
+        <p:txBody>
+          <a:bodyPr rtlCol="0" anchor="ctr" wrap="square" lIns="182880" rIns="182880" tIns="182880"/>
+          <a:lstStyle/>
+          <a:p>
+            <a:pPr algn="ctr">
+              <a:defRPr sz="2200" b="1">
+                <a:solidFill>
+                  <a:srgbClr val="2563EB"/>
+                </a:solidFill>
+                <a:latin typeface="Arial"/>
+              </a:defRPr>
+            </a:pPr>
+            <a:r>
+              <a:t>75 000+</a:t>
+            </a:r>
+          </a:p>
+          <a:p>
+            <a:pPr>
+              <a:spcBef>
+                <a:spcPts val="400"/>
+              </a:spcBef>
+              <a:defRPr sz="1000" b="1">
+                <a:solidFill>
+                  <a:srgbClr val="0F172A"/>
+                </a:solidFill>
+                <a:latin typeface="Arial"/>
+              </a:defRPr>
+            </a:pPr>
+            <a:r>
+              <a:t>Госгрантов в РК с жестким конкурсом</a:t>
+            </a:r>
+          </a:p>
+        </p:txBody>
+      </p:sp>
+      <p:sp>
+        <p:nvSpPr>
+          <p:cNvPr id="10" name="Rounded Rectangle 9"/>
+          <p:cNvSpPr/>
+          <p:nvPr/>
+        </p:nvSpPr>
+        <p:spPr>
+          <a:xfrm>
+            <a:off x="3337560" y="4206240"/>
+            <a:ext cx="2468880" cy="1874519"/>
+          </a:xfrm>
+          <a:prstGeom prst="roundRect">
+            <a:avLst/>
+          </a:prstGeom>
+          <a:solidFill>
+            <a:srgbClr val="FFFFFF"/>
+          </a:solidFill>
+          <a:ln>
+            <a:solidFill>
+              <a:srgbClr val="E2E8F0"/>
+            </a:solidFill>
+          </a:ln>
+        </p:spPr>
+        <p:style>
+          <a:lnRef idx="1">
+            <a:schemeClr val="accent1"/>
+          </a:lnRef>
+          <a:fillRef idx="3">
+            <a:schemeClr val="accent1"/>
+          </a:fillRef>
+          <a:effectRef idx="2">
+            <a:schemeClr val="accent1"/>
+          </a:effectRef>
+          <a:fontRef idx="minor">
+            <a:schemeClr val="lt1"/>
+          </a:fontRef>
+        </p:style>
+        <p:txBody>
+          <a:bodyPr rtlCol="0" anchor="ctr" wrap="square" lIns="182880" rIns="182880" tIns="182880"/>
+          <a:lstStyle/>
+          <a:p>
+            <a:pPr algn="ctr">
+              <a:defRPr sz="2200" b="1">
+                <a:solidFill>
+                  <a:srgbClr val="2563EB"/>
+                </a:solidFill>
+                <a:latin typeface="Arial"/>
+              </a:defRPr>
+            </a:pPr>
+            <a:r>
+              <a:t>+38%</a:t>
+            </a:r>
+          </a:p>
+          <a:p>
+            <a:pPr>
+              <a:spcBef>
+                <a:spcPts val="400"/>
+              </a:spcBef>
+              <a:defRPr sz="1000" b="1">
+                <a:solidFill>
+                  <a:srgbClr val="0F172A"/>
+                </a:solidFill>
+                <a:latin typeface="Arial"/>
+              </a:defRPr>
+            </a:pPr>
+            <a:r>
+              <a:t>Ежегодный рост запросов на стипендии</a:t>
+            </a:r>
+          </a:p>
+        </p:txBody>
+      </p:sp>
+      <p:sp>
+        <p:nvSpPr>
+          <p:cNvPr id="11" name="TextBox 10"/>
+          <p:cNvSpPr txBox="1"/>
+          <p:nvPr/>
+        </p:nvSpPr>
+        <p:spPr>
+          <a:xfrm>
+            <a:off x="6217920" y="1783080"/>
+            <a:ext cx="5212080" cy="320040"/>
+          </a:xfrm>
+          <a:prstGeom prst="rect">
+            <a:avLst/>
+          </a:prstGeom>
+          <a:noFill/>
+        </p:spPr>
+        <p:txBody>
+          <a:bodyPr wrap="none">
+            <a:spAutoFit/>
+          </a:bodyPr>
+          <a:lstStyle/>
+          <a:p>
+            <a:pPr>
+              <a:defRPr sz="1100" b="1">
+                <a:solidFill>
+                  <a:srgbClr val="10B981"/>
+                </a:solidFill>
+              </a:defRPr>
+            </a:pPr>
+            <a:r>
+              <a:t>ТАРИФЫ И ИСТОЧНИКИ ВЫРУЧКИ</a:t>
+            </a:r>
+          </a:p>
+        </p:txBody>
+      </p:sp>
+      <p:sp>
+        <p:nvSpPr>
+          <p:cNvPr id="12" name="Rounded Rectangle 11"/>
+          <p:cNvSpPr/>
+          <p:nvPr/>
+        </p:nvSpPr>
+        <p:spPr>
+          <a:xfrm>
+            <a:off x="6217920" y="2148840"/>
+            <a:ext cx="5212080" cy="1234440"/>
+          </a:xfrm>
+          <a:prstGeom prst="roundRect">
+            <a:avLst/>
+          </a:prstGeom>
+          <a:solidFill>
+            <a:srgbClr val="FFFFFF"/>
+          </a:solidFill>
+          <a:ln>
+            <a:solidFill>
+              <a:srgbClr val="E2E8F0"/>
+            </a:solidFill>
+          </a:ln>
+        </p:spPr>
+        <p:style>
+          <a:lnRef idx="1">
+            <a:schemeClr val="accent1"/>
+          </a:lnRef>
+          <a:fillRef idx="3">
+            <a:schemeClr val="accent1"/>
+          </a:fillRef>
+          <a:effectRef idx="2">
+            <a:schemeClr val="accent1"/>
+          </a:effectRef>
+          <a:fontRef idx="minor">
+            <a:schemeClr val="lt1"/>
+          </a:fontRef>
+        </p:style>
+        <p:txBody>
+          <a:bodyPr rtlCol="0" anchor="ctr" wrap="square" lIns="228600" rIns="228600" tIns="137160"/>
+          <a:lstStyle/>
+          <a:p>
+            <a:pPr algn="ctr">
+              <a:defRPr sz="1200" b="1">
+                <a:solidFill>
+                  <a:srgbClr val="0F172A"/>
+                </a:solidFill>
+                <a:latin typeface="Arial"/>
+              </a:defRPr>
+            </a:pPr>
+            <a:r>
+              <a:t>FREEMIUM (0 ₸)</a:t>
+            </a:r>
+          </a:p>
+          <a:p>
+            <a:pPr>
+              <a:spcBef>
+                <a:spcPts val="300"/>
+              </a:spcBef>
+              <a:defRPr sz="1000">
+                <a:solidFill>
                   <a:srgbClr val="64748B"/>
                 </a:solidFill>
                 <a:latin typeface="Arial"/>
               </a:defRPr>
             </a:pPr>
             <a:r>
-              <a:t>B2B ПАРТНЕРСТВО</a:t>
-            </a:r>
-          </a:p>
-          <a:p>
-            <a:pPr>
-              <a:spcBef>
-                <a:spcPts val="400"/>
-              </a:spcBef>
-              <a:defRPr sz="2200" b="1">
+              <a:t>Широкий органический охват: топ-36 вузов, расчет шансов, базовый роадмап.</a:t>
+            </a:r>
+          </a:p>
+        </p:txBody>
+      </p:sp>
+      <p:sp>
+        <p:nvSpPr>
+          <p:cNvPr id="13" name="Rounded Rectangle 12"/>
+          <p:cNvSpPr/>
+          <p:nvPr/>
+        </p:nvSpPr>
+        <p:spPr>
+          <a:xfrm>
+            <a:off x="6217920" y="3520440"/>
+            <a:ext cx="5212080" cy="1234440"/>
+          </a:xfrm>
+          <a:prstGeom prst="roundRect">
+            <a:avLst/>
+          </a:prstGeom>
+          <a:solidFill>
+            <a:srgbClr val="EEF2FF"/>
+          </a:solidFill>
+          <a:ln>
+            <a:solidFill>
+              <a:srgbClr val="2563EB"/>
+            </a:solidFill>
+          </a:ln>
+        </p:spPr>
+        <p:style>
+          <a:lnRef idx="1">
+            <a:schemeClr val="accent1"/>
+          </a:lnRef>
+          <a:fillRef idx="3">
+            <a:schemeClr val="accent1"/>
+          </a:fillRef>
+          <a:effectRef idx="2">
+            <a:schemeClr val="accent1"/>
+          </a:effectRef>
+          <a:fontRef idx="minor">
+            <a:schemeClr val="lt1"/>
+          </a:fontRef>
+        </p:style>
+        <p:txBody>
+          <a:bodyPr rtlCol="0" anchor="ctr" wrap="square" lIns="228600" rIns="228600" tIns="137160"/>
+          <a:lstStyle/>
+          <a:p>
+            <a:pPr algn="ctr">
+              <a:defRPr sz="1200" b="1">
+                <a:solidFill>
+                  <a:srgbClr val="2563EB"/>
+                </a:solidFill>
+                <a:latin typeface="Arial"/>
+              </a:defRPr>
+            </a:pPr>
+            <a:r>
+              <a:t>ADMITROUTE PRO (4 990 ₸ / мес)</a:t>
+            </a:r>
+          </a:p>
+          <a:p>
+            <a:pPr>
+              <a:spcBef>
+                <a:spcPts val="300"/>
+              </a:spcBef>
+              <a:defRPr sz="1000">
+                <a:solidFill>
+                  <a:srgbClr val="64748B"/>
+                </a:solidFill>
+                <a:latin typeface="Arial"/>
+              </a:defRPr>
+            </a:pPr>
+            <a:r>
+              <a:t>Безлимитный AI-поиск любого вуза мира, конструктор эссе, трекер дедлайнов и чат.</a:t>
+            </a:r>
+          </a:p>
+        </p:txBody>
+      </p:sp>
+      <p:sp>
+        <p:nvSpPr>
+          <p:cNvPr id="14" name="Rounded Rectangle 13"/>
+          <p:cNvSpPr/>
+          <p:nvPr/>
+        </p:nvSpPr>
+        <p:spPr>
+          <a:xfrm>
+            <a:off x="6217920" y="4892040"/>
+            <a:ext cx="5212080" cy="1234440"/>
+          </a:xfrm>
+          <a:prstGeom prst="roundRect">
+            <a:avLst/>
+          </a:prstGeom>
+          <a:solidFill>
+            <a:srgbClr val="FFFFFF"/>
+          </a:solidFill>
+          <a:ln>
+            <a:solidFill>
+              <a:srgbClr val="E2E8F0"/>
+            </a:solidFill>
+          </a:ln>
+        </p:spPr>
+        <p:style>
+          <a:lnRef idx="1">
+            <a:schemeClr val="accent1"/>
+          </a:lnRef>
+          <a:fillRef idx="3">
+            <a:schemeClr val="accent1"/>
+          </a:fillRef>
+          <a:effectRef idx="2">
+            <a:schemeClr val="accent1"/>
+          </a:effectRef>
+          <a:fontRef idx="minor">
+            <a:schemeClr val="lt1"/>
+          </a:fontRef>
+        </p:style>
+        <p:txBody>
+          <a:bodyPr rtlCol="0" anchor="ctr" wrap="square" lIns="228600" rIns="228600" tIns="137160"/>
+          <a:lstStyle/>
+          <a:p>
+            <a:pPr algn="ctr">
+              <a:defRPr sz="1200" b="1">
                 <a:solidFill>
                   <a:srgbClr val="0F172A"/>
                 </a:solidFill>
@@ -6632,29 +7503,13 @@
               </a:defRPr>
             </a:pPr>
             <a:r>
-              <a:t>Индивидуально</a:t>
-            </a:r>
-          </a:p>
-          <a:p>
-            <a:pPr>
-              <a:spcBef>
-                <a:spcPts val="200"/>
-              </a:spcBef>
-              <a:defRPr sz="1500" b="1">
-                <a:solidFill>
-                  <a:srgbClr val="0F172A"/>
-                </a:solidFill>
-                <a:latin typeface="Arial"/>
-              </a:defRPr>
-            </a:pPr>
-            <a:r>
-              <a:t>Для школ и центров</a:t>
-            </a:r>
-          </a:p>
-          <a:p>
-            <a:pPr>
-              <a:spcBef>
-                <a:spcPts val="400"/>
+              <a:t>B2B ПАРТНЕРСТВО (По запросу)</a:t>
+            </a:r>
+          </a:p>
+          <a:p>
+            <a:pPr>
+              <a:spcBef>
+                <a:spcPts val="300"/>
               </a:spcBef>
               <a:defRPr sz="1000">
                 <a:solidFill>
@@ -6664,71 +7519,7 @@
               </a:defRPr>
             </a:pPr>
             <a:r>
-              <a:t>Инструмент для образовательных центров и языковых школ:</a:t>
-            </a:r>
-          </a:p>
-          <a:p>
-            <a:pPr>
-              <a:spcBef>
-                <a:spcPts val="600"/>
-              </a:spcBef>
-              <a:defRPr sz="1000">
-                <a:solidFill>
-                  <a:srgbClr val="0F172A"/>
-                </a:solidFill>
-                <a:latin typeface="Arial"/>
-              </a:defRPr>
-            </a:pPr>
-            <a:r>
-              <a:t>• Кабинет консультанта и профориентатора</a:t>
-            </a:r>
-          </a:p>
-          <a:p>
-            <a:pPr>
-              <a:spcBef>
-                <a:spcPts val="600"/>
-              </a:spcBef>
-              <a:defRPr sz="1000">
-                <a:solidFill>
-                  <a:srgbClr val="0F172A"/>
-                </a:solidFill>
-                <a:latin typeface="Arial"/>
-              </a:defRPr>
-            </a:pPr>
-            <a:r>
-              <a:t>• Отслеживание дедлайнов учеников класса</a:t>
-            </a:r>
-          </a:p>
-          <a:p>
-            <a:pPr>
-              <a:spcBef>
-                <a:spcPts val="600"/>
-              </a:spcBef>
-              <a:defRPr sz="1000">
-                <a:solidFill>
-                  <a:srgbClr val="0F172A"/>
-                </a:solidFill>
-                <a:latin typeface="Arial"/>
-              </a:defRPr>
-            </a:pPr>
-            <a:r>
-              <a:t>• White-label отчеты для родителей</a:t>
-            </a:r>
-          </a:p>
-          <a:p>
-            <a:pPr>
-              <a:spcBef>
-                <a:spcPts val="600"/>
-              </a:spcBef>
-              <a:defRPr sz="1000">
-                <a:solidFill>
-                  <a:srgbClr val="0F172A"/>
-                </a:solidFill>
-                <a:latin typeface="Arial"/>
-              </a:defRPr>
-            </a:pPr>
-            <a:r>
-              <a:t>• Пакетные скидки на подписки PRO</a:t>
+              <a:t>Для школ и центров: дашборд учеников, шеринг-отчеты родителям, пакетные скидки.</a:t>
             </a:r>
           </a:p>
         </p:txBody>
@@ -6810,7 +7601,7 @@
         </p:blipFill>
         <p:spPr>
           <a:xfrm>
-            <a:off x="822960" y="822960"/>
+            <a:off x="822960" y="731520"/>
             <a:ext cx="1371600" cy="1371600"/>
           </a:xfrm>
           <a:prstGeom prst="rect">
@@ -6826,8 +7617,8 @@
         </p:nvSpPr>
         <p:spPr>
           <a:xfrm>
-            <a:off x="822960" y="2194560"/>
-            <a:ext cx="10515600" cy="1645920"/>
+            <a:off x="822960" y="1920240"/>
+            <a:ext cx="10515600" cy="1280160"/>
           </a:xfrm>
           <a:prstGeom prst="rect">
             <a:avLst/>
@@ -6841,7 +7632,7 @@
           <a:lstStyle/>
           <a:p>
             <a:pPr>
-              <a:defRPr sz="3600" b="1">
+              <a:defRPr sz="3200" b="1">
                 <a:solidFill>
                   <a:srgbClr val="FFFFFF"/>
                 </a:solidFill>
@@ -6855,9 +7646,9 @@
           <a:p>
             <a:pPr>
               <a:spcBef>
-                <a:spcPts val="800"/>
-              </a:spcBef>
-              <a:defRPr sz="1500">
+                <a:spcPts val="400"/>
+              </a:spcBef>
+              <a:defRPr sz="1400">
                 <a:solidFill>
                   <a:srgbClr val="94A3B8"/>
                 </a:solidFill>
@@ -6865,7 +7656,7 @@
               </a:defRPr>
             </a:pPr>
             <a:r>
-              <a:t>Проект создан в рамках LOCUS Startup Hackathon 2026 (Кейс 02: Персональный маршрут поступления, код LOCUSCASE2).</a:t>
+              <a:t>Создан для LOCUS Hackathon 2026 (Кейс 02, код LOCUSCASE2). Готов к масштабированию.</a:t>
             </a:r>
           </a:p>
         </p:txBody>
@@ -6878,8 +7669,8 @@
         </p:nvSpPr>
         <p:spPr>
           <a:xfrm>
-            <a:off x="822960" y="4114800"/>
-            <a:ext cx="3383280" cy="2011680"/>
+            <a:off x="822960" y="3337560"/>
+            <a:ext cx="10515600" cy="777240"/>
           </a:xfrm>
           <a:prstGeom prst="roundRect">
             <a:avLst/>
@@ -6908,51 +7699,33 @@
           </a:fontRef>
         </p:style>
         <p:txBody>
-          <a:bodyPr rtlCol="0" anchor="ctr" wrap="square" lIns="228600" rIns="228600" tIns="228600"/>
+          <a:bodyPr rtlCol="0" anchor="ctr" wrap="square" lIns="228600" tIns="109728"/>
           <a:lstStyle/>
           <a:p>
             <a:pPr algn="ctr">
-              <a:defRPr sz="1000" b="1">
+              <a:defRPr sz="950" b="1">
                 <a:solidFill>
                   <a:srgbClr val="38BDF8"/>
                 </a:solidFill>
-                <a:latin typeface="Arial"/>
-              </a:defRPr>
-            </a:pPr>
-            <a:r>
-              <a:t>ОСНОВАТЕЛЬ И РАЗРАБОТКА</a:t>
-            </a:r>
-          </a:p>
-          <a:p>
-            <a:pPr>
-              <a:spcBef>
-                <a:spcPts val="600"/>
-              </a:spcBef>
-              <a:defRPr sz="1600" b="1">
+              </a:defRPr>
+            </a:pPr>
+            <a:r>
+              <a:t>ТЕХНОЛОГИЧЕСКИЙ СТЕК:</a:t>
+            </a:r>
+          </a:p>
+          <a:p>
+            <a:pPr>
+              <a:spcBef>
+                <a:spcPts val="200"/>
+              </a:spcBef>
+              <a:defRPr sz="1150" b="1">
                 <a:solidFill>
                   <a:srgbClr val="FFFFFF"/>
                 </a:solidFill>
-                <a:latin typeface="Arial"/>
-              </a:defRPr>
-            </a:pPr>
-            <a:r>
-              <a:t>Адильхан</a:t>
-            </a:r>
-          </a:p>
-          <a:p>
-            <a:pPr>
-              <a:spcBef>
-                <a:spcPts val="400"/>
-              </a:spcBef>
-              <a:defRPr sz="1100">
-                <a:solidFill>
-                  <a:srgbClr val="94A3B8"/>
-                </a:solidFill>
-                <a:latin typeface="Arial"/>
-              </a:defRPr>
-            </a:pPr>
-            <a:r>
-              <a:t>Product &amp; Engineering</a:t>
+              </a:defRPr>
+            </a:pPr>
+            <a:r>
+              <a:t>Google Gemini 3.6 Flash • Neon Serverless PostgreSQL (AWS) • React 19 / TypeScript • Telegram Bot Webhooks</a:t>
             </a:r>
           </a:p>
         </p:txBody>
@@ -6965,8 +7738,8 @@
         </p:nvSpPr>
         <p:spPr>
           <a:xfrm>
-            <a:off x="4480560" y="4114800"/>
-            <a:ext cx="3383280" cy="2011680"/>
+            <a:off x="822960" y="4343400"/>
+            <a:ext cx="3383280" cy="1920240"/>
           </a:xfrm>
           <a:prstGeom prst="roundRect">
             <a:avLst/>
@@ -6995,7 +7768,7 @@
           </a:fontRef>
         </p:style>
         <p:txBody>
-          <a:bodyPr rtlCol="0" anchor="ctr" wrap="square" lIns="228600" rIns="228600" tIns="228600"/>
+          <a:bodyPr rtlCol="0" anchor="ctr" wrap="square" lIns="228600" rIns="228600" tIns="182880"/>
           <a:lstStyle/>
           <a:p>
             <a:pPr algn="ctr">
@@ -7007,13 +7780,13 @@
               </a:defRPr>
             </a:pPr>
             <a:r>
-              <a:t>WHATSAPP / ТЕЛЕФОН</a:t>
-            </a:r>
-          </a:p>
-          <a:p>
-            <a:pPr>
-              <a:spcBef>
-                <a:spcPts val="600"/>
+              <a:t>ОСНОВАТЕЛЬ И РАЗРАБОТКА</a:t>
+            </a:r>
+          </a:p>
+          <a:p>
+            <a:pPr>
+              <a:spcBef>
+                <a:spcPts val="400"/>
               </a:spcBef>
               <a:defRPr sz="1600" b="1">
                 <a:solidFill>
@@ -7023,7 +7796,7 @@
               </a:defRPr>
             </a:pPr>
             <a:r>
-              <a:t>+7 775 253 01 10</a:t>
+              <a:t>Адильхан</a:t>
             </a:r>
           </a:p>
           <a:p>
@@ -7039,7 +7812,7 @@
               </a:defRPr>
             </a:pPr>
             <a:r>
-              <a:t>Прямая связь и оформление PRO</a:t>
+              <a:t>Product &amp; Engineering</a:t>
             </a:r>
           </a:p>
         </p:txBody>
@@ -7052,8 +7825,8 @@
         </p:nvSpPr>
         <p:spPr>
           <a:xfrm>
-            <a:off x="8138160" y="4114800"/>
-            <a:ext cx="3383280" cy="2011680"/>
+            <a:off x="4480560" y="4343400"/>
+            <a:ext cx="3383280" cy="1920240"/>
           </a:xfrm>
           <a:prstGeom prst="roundRect">
             <a:avLst/>
@@ -7082,7 +7855,7 @@
           </a:fontRef>
         </p:style>
         <p:txBody>
-          <a:bodyPr rtlCol="0" anchor="ctr" wrap="square" lIns="228600" rIns="228600" tIns="228600"/>
+          <a:bodyPr rtlCol="0" anchor="ctr" wrap="square" lIns="228600" rIns="228600" tIns="182880"/>
           <a:lstStyle/>
           <a:p>
             <a:pPr algn="ctr">
@@ -7094,13 +7867,100 @@
               </a:defRPr>
             </a:pPr>
             <a:r>
+              <a:t>WHATSAPP / ТЕЛЕФОН</a:t>
+            </a:r>
+          </a:p>
+          <a:p>
+            <a:pPr>
+              <a:spcBef>
+                <a:spcPts val="400"/>
+              </a:spcBef>
+              <a:defRPr sz="1600" b="1">
+                <a:solidFill>
+                  <a:srgbClr val="FFFFFF"/>
+                </a:solidFill>
+                <a:latin typeface="Arial"/>
+              </a:defRPr>
+            </a:pPr>
+            <a:r>
+              <a:t>+7 775 253 01 10</a:t>
+            </a:r>
+          </a:p>
+          <a:p>
+            <a:pPr>
+              <a:spcBef>
+                <a:spcPts val="400"/>
+              </a:spcBef>
+              <a:defRPr sz="1100">
+                <a:solidFill>
+                  <a:srgbClr val="94A3B8"/>
+                </a:solidFill>
+                <a:latin typeface="Arial"/>
+              </a:defRPr>
+            </a:pPr>
+            <a:r>
+              <a:t>Прямая связь и оформление PRO</a:t>
+            </a:r>
+          </a:p>
+        </p:txBody>
+      </p:sp>
+      <p:sp>
+        <p:nvSpPr>
+          <p:cNvPr id="8" name="Rounded Rectangle 7"/>
+          <p:cNvSpPr/>
+          <p:nvPr/>
+        </p:nvSpPr>
+        <p:spPr>
+          <a:xfrm>
+            <a:off x="8138160" y="4343400"/>
+            <a:ext cx="3383280" cy="1920240"/>
+          </a:xfrm>
+          <a:prstGeom prst="roundRect">
+            <a:avLst/>
+          </a:prstGeom>
+          <a:solidFill>
+            <a:srgbClr val="1E293B"/>
+          </a:solidFill>
+          <a:ln>
+            <a:solidFill>
+              <a:srgbClr val="334155"/>
+            </a:solidFill>
+          </a:ln>
+        </p:spPr>
+        <p:style>
+          <a:lnRef idx="1">
+            <a:schemeClr val="accent1"/>
+          </a:lnRef>
+          <a:fillRef idx="3">
+            <a:schemeClr val="accent1"/>
+          </a:fillRef>
+          <a:effectRef idx="2">
+            <a:schemeClr val="accent1"/>
+          </a:effectRef>
+          <a:fontRef idx="minor">
+            <a:schemeClr val="lt1"/>
+          </a:fontRef>
+        </p:style>
+        <p:txBody>
+          <a:bodyPr rtlCol="0" anchor="ctr" wrap="square" lIns="228600" rIns="228600" tIns="182880"/>
+          <a:lstStyle/>
+          <a:p>
+            <a:pPr algn="ctr">
+              <a:defRPr sz="1000" b="1">
+                <a:solidFill>
+                  <a:srgbClr val="38BDF8"/>
+                </a:solidFill>
+                <a:latin typeface="Arial"/>
+              </a:defRPr>
+            </a:pPr>
+            <a:r>
               <a:t>TELEGRAM</a:t>
             </a:r>
           </a:p>
           <a:p>
             <a:pPr>
               <a:spcBef>
-                <a:spcPts val="600"/>
+                <a:spcPts val="400"/>
               </a:spcBef>
               <a:defRPr sz="1600" b="1">
                 <a:solidFill>

</xml_diff>